<commit_message>
Rewrite HE-2 slides to match intro style and focus.
Light layout like Ezagutzea-Sarrera; content centers on what recon-ng and SpiderFoot are, what they are for, and what to keep in mind (API keys).

Co-authored-by: jazkune-izarraitz <jazkune-izarraitz@users.noreply.github.com>
</commit_message>
<xml_diff>
--- a/he-ezagutzea/HE-2-recon-ng-spiderfoot-aurkezpena.pptx
+++ b/he-ezagutzea/HE-2-recon-ng-spiderfoot-aurkezpena.pptx
@@ -25,10 +25,6 @@
     <p:sldId id="273" r:id="rId24"/>
     <p:sldId id="274" r:id="rId25"/>
     <p:sldId id="275" r:id="rId26"/>
-    <p:sldId id="276" r:id="rId27"/>
-    <p:sldId id="277" r:id="rId28"/>
-    <p:sldId id="278" r:id="rId29"/>
-    <p:sldId id="279" r:id="rId30"/>
   </p:sldIdLst>
   <p:sldSz cx="12191695" cy="6858000" type="screen4x3"/>
   <p:notesSz cx="6858000" cy="9144000"/>
@@ -3107,7 +3103,7 @@
     <p:bg>
       <p:bgPr>
         <a:solidFill>
-          <a:srgbClr val="0F1419"/>
+          <a:srgbClr val="E9EDEE"/>
         </a:solidFill>
         <a:effectLst/>
       </p:bgPr>
@@ -3127,28 +3123,28 @@
         </p:nvSpPr>
         <p:spPr>
           <a:xfrm>
-            <a:off x="822960" y="2194560"/>
-            <a:ext cx="10058400" cy="1097280"/>
-          </a:xfrm>
-          <a:prstGeom prst="rect">
-            <a:avLst/>
-          </a:prstGeom>
-          <a:noFill/>
-        </p:spPr>
-        <p:txBody>
-          <a:bodyPr wrap="square">
-            <a:spAutoFit/>
-          </a:bodyPr>
-          <a:lstStyle/>
-          <a:p>
-            <a:r>
-              <a:rPr sz="4400" b="1">
-                <a:solidFill>
-                  <a:srgbClr val="E8EEF4"/>
-                </a:solidFill>
-                <a:latin typeface="Calibri"/>
-              </a:rPr>
-              <a:t>Ezagutzea (Footprinting)</a:t>
+            <a:off x="822960" y="2468880"/>
+            <a:ext cx="10515600" cy="1097280"/>
+          </a:xfrm>
+          <a:prstGeom prst="rect">
+            <a:avLst/>
+          </a:prstGeom>
+          <a:noFill/>
+        </p:spPr>
+        <p:txBody>
+          <a:bodyPr wrap="none">
+            <a:spAutoFit/>
+          </a:bodyPr>
+          <a:lstStyle/>
+          <a:p>
+            <a:r>
+              <a:rPr sz="4200" b="1" i="0">
+                <a:solidFill>
+                  <a:srgbClr val="1A1A1A"/>
+                </a:solidFill>
+                <a:latin typeface="Raleway"/>
+              </a:rPr>
+              <a:t>Ezagutzea — Tresnak</a:t>
             </a:r>
           </a:p>
         </p:txBody>
@@ -3161,28 +3157,28 @@
         </p:nvSpPr>
         <p:spPr>
           <a:xfrm>
-            <a:off x="822960" y="3383280"/>
-            <a:ext cx="10058400" cy="548640"/>
-          </a:xfrm>
-          <a:prstGeom prst="rect">
-            <a:avLst/>
-          </a:prstGeom>
-          <a:noFill/>
-        </p:spPr>
-        <p:txBody>
-          <a:bodyPr wrap="square">
-            <a:spAutoFit/>
-          </a:bodyPr>
-          <a:lstStyle/>
-          <a:p>
-            <a:r>
-              <a:rPr sz="2600" b="0">
-                <a:solidFill>
-                  <a:srgbClr val="9AABBC"/>
-                </a:solidFill>
-                <a:latin typeface="Calibri"/>
-              </a:rPr>
-              <a:t>Tresnak: recon-ng eta SpiderFoot</a:t>
+            <a:off x="822960" y="3566160"/>
+            <a:ext cx="10515600" cy="457200"/>
+          </a:xfrm>
+          <a:prstGeom prst="rect">
+            <a:avLst/>
+          </a:prstGeom>
+          <a:noFill/>
+        </p:spPr>
+        <p:txBody>
+          <a:bodyPr wrap="none">
+            <a:spAutoFit/>
+          </a:bodyPr>
+          <a:lstStyle/>
+          <a:p>
+            <a:r>
+              <a:rPr sz="1600" b="0" i="0">
+                <a:solidFill>
+                  <a:srgbClr val="595959"/>
+                </a:solidFill>
+                <a:latin typeface="Raleway"/>
+              </a:rPr>
+              <a:t>recon-ng eta SpiderFoot</a:t>
             </a:r>
           </a:p>
         </p:txBody>
@@ -3196,27 +3192,27 @@
         <p:spPr>
           <a:xfrm>
             <a:off x="822960" y="4023360"/>
-            <a:ext cx="10058400" cy="457200"/>
-          </a:xfrm>
-          <a:prstGeom prst="rect">
-            <a:avLst/>
-          </a:prstGeom>
-          <a:noFill/>
-        </p:spPr>
-        <p:txBody>
-          <a:bodyPr wrap="square">
-            <a:spAutoFit/>
-          </a:bodyPr>
-          <a:lstStyle/>
-          <a:p>
-            <a:r>
-              <a:rPr sz="2200" b="0">
-                <a:solidFill>
-                  <a:srgbClr val="9AABBC"/>
-                </a:solidFill>
-                <a:latin typeface="Calibri"/>
-              </a:rPr>
-              <a:t>Hacking etikoa — Kali Linux</a:t>
+            <a:ext cx="10515600" cy="457200"/>
+          </a:xfrm>
+          <a:prstGeom prst="rect">
+            <a:avLst/>
+          </a:prstGeom>
+          <a:noFill/>
+        </p:spPr>
+        <p:txBody>
+          <a:bodyPr wrap="none">
+            <a:spAutoFit/>
+          </a:bodyPr>
+          <a:lstStyle/>
+          <a:p>
+            <a:r>
+              <a:rPr sz="1600" b="0" i="0">
+                <a:solidFill>
+                  <a:srgbClr val="595959"/>
+                </a:solidFill>
+                <a:latin typeface="Raleway"/>
+              </a:rPr>
+              <a:t>Hacking etikoa</a:t>
             </a:r>
           </a:p>
         </p:txBody>
@@ -3235,7 +3231,7 @@
     <p:bg>
       <p:bgPr>
         <a:solidFill>
-          <a:srgbClr val="0F1419"/>
+          <a:srgbClr val="E9EDEE"/>
         </a:solidFill>
         <a:effectLst/>
       </p:bgPr>
@@ -3255,74 +3251,63 @@
         </p:nvSpPr>
         <p:spPr>
           <a:xfrm>
-            <a:off x="822960" y="914400"/>
-            <a:ext cx="10058400" cy="640080"/>
-          </a:xfrm>
-          <a:prstGeom prst="rect">
-            <a:avLst/>
-          </a:prstGeom>
-          <a:noFill/>
-        </p:spPr>
-        <p:txBody>
-          <a:bodyPr wrap="square">
-            <a:spAutoFit/>
-          </a:bodyPr>
-          <a:lstStyle/>
-          <a:p>
-            <a:r>
-              <a:rPr sz="3600" b="1">
-                <a:solidFill>
-                  <a:srgbClr val="3D9EE5"/>
-                </a:solidFill>
-                <a:latin typeface="Calibri"/>
-              </a:rPr>
-              <a:t>Kali-n abiarazi</a:t>
-            </a:r>
-          </a:p>
-        </p:txBody>
-      </p:sp>
-      <p:sp>
-        <p:nvSpPr>
-          <p:cNvPr id="3" name="Rounded Rectangle 2"/>
-          <p:cNvSpPr/>
-          <p:nvPr/>
-        </p:nvSpPr>
-        <p:spPr>
-          <a:xfrm>
-            <a:off x="822960" y="2011680"/>
-            <a:ext cx="10058400" cy="2560320"/>
-          </a:xfrm>
-          <a:prstGeom prst="roundRect">
-            <a:avLst/>
-          </a:prstGeom>
-          <a:solidFill>
-            <a:srgbClr val="1A2332"/>
-          </a:solidFill>
-          <a:ln>
-            <a:solidFill>
-              <a:srgbClr val="2A3A4D"/>
-            </a:solidFill>
-          </a:ln>
-        </p:spPr>
-        <p:style>
-          <a:lnRef idx="1">
-            <a:schemeClr val="accent1"/>
-          </a:lnRef>
-          <a:fillRef idx="3">
-            <a:schemeClr val="accent1"/>
-          </a:fillRef>
-          <a:effectRef idx="2">
-            <a:schemeClr val="accent1"/>
-          </a:effectRef>
-          <a:fontRef idx="minor">
-            <a:schemeClr val="lt1"/>
-          </a:fontRef>
-        </p:style>
-        <p:txBody>
-          <a:bodyPr rtlCol="0" anchor="ctr"/>
-          <a:lstStyle/>
-          <a:p>
-            <a:pPr algn="ctr"/>
+            <a:off x="822960" y="822960"/>
+            <a:ext cx="10515600" cy="822960"/>
+          </a:xfrm>
+          <a:prstGeom prst="rect">
+            <a:avLst/>
+          </a:prstGeom>
+          <a:noFill/>
+        </p:spPr>
+        <p:txBody>
+          <a:bodyPr wrap="square">
+            <a:spAutoFit/>
+          </a:bodyPr>
+          <a:lstStyle/>
+          <a:p>
+            <a:r>
+              <a:rPr sz="2400" b="1" i="0">
+                <a:solidFill>
+                  <a:srgbClr val="1A1A1A"/>
+                </a:solidFill>
+                <a:latin typeface="Raleway"/>
+              </a:rPr>
+              <a:t>Nola antolatzen da</a:t>
+            </a:r>
+          </a:p>
+        </p:txBody>
+      </p:sp>
+      <p:sp>
+        <p:nvSpPr>
+          <p:cNvPr id="3" name="TextBox 2"/>
+          <p:cNvSpPr txBox="1"/>
+          <p:nvPr/>
+        </p:nvSpPr>
+        <p:spPr>
+          <a:xfrm>
+            <a:off x="822960" y="2286000"/>
+            <a:ext cx="10515600" cy="777240"/>
+          </a:xfrm>
+          <a:prstGeom prst="rect">
+            <a:avLst/>
+          </a:prstGeom>
+          <a:noFill/>
+        </p:spPr>
+        <p:txBody>
+          <a:bodyPr wrap="square">
+            <a:spAutoFit/>
+          </a:bodyPr>
+          <a:lstStyle/>
+          <a:p>
+            <a:r>
+              <a:rPr sz="2600" b="0" i="1">
+                <a:solidFill>
+                  <a:srgbClr val="1A1A1A"/>
+                </a:solidFill>
+                <a:latin typeface="Raleway"/>
+              </a:rPr>
+              <a:t>Workspaces  →  Modules</a:t>
+            </a:r>
           </a:p>
         </p:txBody>
       </p:sp>
@@ -3334,65 +3319,96 @@
         </p:nvSpPr>
         <p:spPr>
           <a:xfrm>
-            <a:off x="1097280" y="2240280"/>
-            <a:ext cx="9509760" cy="2194560"/>
-          </a:xfrm>
-          <a:prstGeom prst="rect">
-            <a:avLst/>
-          </a:prstGeom>
-          <a:noFill/>
-        </p:spPr>
-        <p:txBody>
-          <a:bodyPr wrap="square">
-            <a:spAutoFit/>
-          </a:bodyPr>
-          <a:lstStyle/>
-          <a:p>
-            <a:pPr>
-              <a:spcAft>
-                <a:spcPts val="400"/>
-              </a:spcAft>
-            </a:pPr>
-            <a:r>
-              <a:rPr sz="1600">
-                <a:solidFill>
-                  <a:srgbClr val="E8EEF4"/>
-                </a:solidFill>
-                <a:latin typeface="Consolas"/>
-              </a:rPr>
-              <a:t>sudo apt update</a:t>
-            </a:r>
-          </a:p>
-          <a:p>
-            <a:pPr>
-              <a:spcAft>
-                <a:spcPts val="400"/>
-              </a:spcAft>
-            </a:pPr>
-            <a:r>
-              <a:rPr sz="1600">
-                <a:solidFill>
-                  <a:srgbClr val="E8EEF4"/>
-                </a:solidFill>
-                <a:latin typeface="Consolas"/>
-              </a:rPr>
-              <a:t>sudo apt install recon-ng</a:t>
-            </a:r>
-          </a:p>
-          <a:p>
-            <a:pPr>
-              <a:spcAft>
-                <a:spcPts val="400"/>
-              </a:spcAft>
-            </a:pPr>
-            <a:r>
-              <a:rPr sz="1600">
-                <a:solidFill>
-                  <a:srgbClr val="E8EEF4"/>
-                </a:solidFill>
-                <a:latin typeface="Consolas"/>
-              </a:rPr>
-              <a:t>recon-ng</a:t>
+            <a:off x="822960" y="3108960"/>
+            <a:ext cx="10515600" cy="777240"/>
+          </a:xfrm>
+          <a:prstGeom prst="rect">
+            <a:avLst/>
+          </a:prstGeom>
+          <a:noFill/>
+        </p:spPr>
+        <p:txBody>
+          <a:bodyPr wrap="square">
+            <a:spAutoFit/>
+          </a:bodyPr>
+          <a:lstStyle/>
+          <a:p>
+            <a:r>
+              <a:rPr sz="2300" b="0" i="0">
+                <a:solidFill>
+                  <a:srgbClr val="1A1A1A"/>
+                </a:solidFill>
+                <a:latin typeface="Raleway"/>
+              </a:rPr>
+              <a:t>- Workspace: helburu edo proiektu bakoitza.</a:t>
+            </a:r>
+          </a:p>
+        </p:txBody>
+      </p:sp>
+      <p:sp>
+        <p:nvSpPr>
+          <p:cNvPr id="5" name="TextBox 4"/>
+          <p:cNvSpPr txBox="1"/>
+          <p:nvPr/>
+        </p:nvSpPr>
+        <p:spPr>
+          <a:xfrm>
+            <a:off x="822960" y="3639312"/>
+            <a:ext cx="10515600" cy="777240"/>
+          </a:xfrm>
+          <a:prstGeom prst="rect">
+            <a:avLst/>
+          </a:prstGeom>
+          <a:noFill/>
+        </p:spPr>
+        <p:txBody>
+          <a:bodyPr wrap="square">
+            <a:spAutoFit/>
+          </a:bodyPr>
+          <a:lstStyle/>
+          <a:p>
+            <a:r>
+              <a:rPr sz="2300" b="0" i="0">
+                <a:solidFill>
+                  <a:srgbClr val="1A1A1A"/>
+                </a:solidFill>
+                <a:latin typeface="Raleway"/>
+              </a:rPr>
+              <a:t>- Module: informazioa biltzeko tresna bakoitza.</a:t>
+            </a:r>
+          </a:p>
+        </p:txBody>
+      </p:sp>
+      <p:sp>
+        <p:nvSpPr>
+          <p:cNvPr id="6" name="TextBox 5"/>
+          <p:cNvSpPr txBox="1"/>
+          <p:nvPr/>
+        </p:nvSpPr>
+        <p:spPr>
+          <a:xfrm>
+            <a:off x="822960" y="4169663"/>
+            <a:ext cx="10515600" cy="777240"/>
+          </a:xfrm>
+          <a:prstGeom prst="rect">
+            <a:avLst/>
+          </a:prstGeom>
+          <a:noFill/>
+        </p:spPr>
+        <p:txBody>
+          <a:bodyPr wrap="square">
+            <a:spAutoFit/>
+          </a:bodyPr>
+          <a:lstStyle/>
+          <a:p>
+            <a:r>
+              <a:rPr sz="2300" b="0" i="0">
+                <a:solidFill>
+                  <a:srgbClr val="1A1A1A"/>
+                </a:solidFill>
+                <a:latin typeface="Raleway"/>
+              </a:rPr>
+              <a:t>- Mailaka nabigatzen da; maila bakoitzean aukera desberdinak.</a:t>
             </a:r>
           </a:p>
         </p:txBody>
@@ -3411,7 +3427,7 @@
     <p:bg>
       <p:bgPr>
         <a:solidFill>
-          <a:srgbClr val="0F1419"/>
+          <a:srgbClr val="E9EDEE"/>
         </a:solidFill>
         <a:effectLst/>
       </p:bgPr>
@@ -3431,28 +3447,28 @@
         </p:nvSpPr>
         <p:spPr>
           <a:xfrm>
-            <a:off x="822960" y="1097280"/>
-            <a:ext cx="10058400" cy="731520"/>
-          </a:xfrm>
-          <a:prstGeom prst="rect">
-            <a:avLst/>
-          </a:prstGeom>
-          <a:noFill/>
-        </p:spPr>
-        <p:txBody>
-          <a:bodyPr wrap="square">
-            <a:spAutoFit/>
-          </a:bodyPr>
-          <a:lstStyle/>
-          <a:p>
-            <a:r>
-              <a:rPr sz="3600" b="1">
-                <a:solidFill>
-                  <a:srgbClr val="3D9EE5"/>
-                </a:solidFill>
-                <a:latin typeface="Calibri"/>
-              </a:rPr>
-              <a:t>Urratsak (klaseko zeregina)</a:t>
+            <a:off x="822960" y="822960"/>
+            <a:ext cx="10515600" cy="822960"/>
+          </a:xfrm>
+          <a:prstGeom prst="rect">
+            <a:avLst/>
+          </a:prstGeom>
+          <a:noFill/>
+        </p:spPr>
+        <p:txBody>
+          <a:bodyPr wrap="square">
+            <a:spAutoFit/>
+          </a:bodyPr>
+          <a:lstStyle/>
+          <a:p>
+            <a:r>
+              <a:rPr sz="2400" b="1" i="0">
+                <a:solidFill>
+                  <a:srgbClr val="1A1A1A"/>
+                </a:solidFill>
+                <a:latin typeface="Raleway"/>
+              </a:rPr>
+              <a:t>recon-ng — zertarako</a:t>
             </a:r>
           </a:p>
         </p:txBody>
@@ -3465,81 +3481,96 @@
         </p:nvSpPr>
         <p:spPr>
           <a:xfrm>
-            <a:off x="822960" y="2194560"/>
-            <a:ext cx="10058400" cy="3657600"/>
-          </a:xfrm>
-          <a:prstGeom prst="rect">
-            <a:avLst/>
-          </a:prstGeom>
-          <a:noFill/>
-        </p:spPr>
-        <p:txBody>
-          <a:bodyPr wrap="square">
-            <a:spAutoFit/>
-          </a:bodyPr>
-          <a:lstStyle/>
-          <a:p>
-            <a:pPr>
-              <a:spcAft>
-                <a:spcPts val="1400"/>
-              </a:spcAft>
-              <a:defRPr sz="2600">
-                <a:solidFill>
-                  <a:srgbClr val="E8EEF4"/>
-                </a:solidFill>
-                <a:latin typeface="Calibri"/>
-              </a:defRPr>
-            </a:pPr>
-            <a:r>
-              <a:t>1. Workspace bat sortu</a:t>
-            </a:r>
-          </a:p>
-          <a:p>
-            <a:pPr>
-              <a:spcAft>
-                <a:spcPts val="1400"/>
-              </a:spcAft>
-              <a:defRPr sz="2600">
-                <a:solidFill>
-                  <a:srgbClr val="E8EEF4"/>
-                </a:solidFill>
-                <a:latin typeface="Calibri"/>
-              </a:defRPr>
-            </a:pPr>
-            <a:r>
-              <a:t>2. Modulu pare bat kargatu</a:t>
-            </a:r>
-          </a:p>
-          <a:p>
-            <a:pPr>
-              <a:spcAft>
-                <a:spcPts val="1400"/>
-              </a:spcAft>
-              <a:defRPr sz="2600">
-                <a:solidFill>
-                  <a:srgbClr val="E8EEF4"/>
-                </a:solidFill>
-                <a:latin typeface="Calibri"/>
-              </a:defRPr>
-            </a:pPr>
-            <a:r>
-              <a:t>3. Domeinu baten gainean exekutatu</a:t>
-            </a:r>
-          </a:p>
-          <a:p>
-            <a:pPr>
-              <a:spcAft>
-                <a:spcPts val="1400"/>
-              </a:spcAft>
-              <a:defRPr sz="2600">
-                <a:solidFill>
-                  <a:srgbClr val="E8EEF4"/>
-                </a:solidFill>
-                <a:latin typeface="Calibri"/>
-              </a:defRPr>
-            </a:pPr>
-            <a:r>
-              <a:t>4. Emaitzarik ez → beste domeinu / modulu</a:t>
+            <a:off x="822960" y="1920240"/>
+            <a:ext cx="10515600" cy="777240"/>
+          </a:xfrm>
+          <a:prstGeom prst="rect">
+            <a:avLst/>
+          </a:prstGeom>
+          <a:noFill/>
+        </p:spPr>
+        <p:txBody>
+          <a:bodyPr wrap="square">
+            <a:spAutoFit/>
+          </a:bodyPr>
+          <a:lstStyle/>
+          <a:p>
+            <a:r>
+              <a:rPr sz="2300" b="0" i="0">
+                <a:solidFill>
+                  <a:srgbClr val="1A1A1A"/>
+                </a:solidFill>
+                <a:latin typeface="Raleway"/>
+              </a:rPr>
+              <a:t>- Domeinu baten gainean moduluak exekutatzeko.</a:t>
+            </a:r>
+          </a:p>
+        </p:txBody>
+      </p:sp>
+      <p:sp>
+        <p:nvSpPr>
+          <p:cNvPr id="4" name="TextBox 3"/>
+          <p:cNvSpPr txBox="1"/>
+          <p:nvPr/>
+        </p:nvSpPr>
+        <p:spPr>
+          <a:xfrm>
+            <a:off x="822960" y="2450592"/>
+            <a:ext cx="10515600" cy="777240"/>
+          </a:xfrm>
+          <a:prstGeom prst="rect">
+            <a:avLst/>
+          </a:prstGeom>
+          <a:noFill/>
+        </p:spPr>
+        <p:txBody>
+          <a:bodyPr wrap="square">
+            <a:spAutoFit/>
+          </a:bodyPr>
+          <a:lstStyle/>
+          <a:p>
+            <a:r>
+              <a:rPr sz="2300" b="0" i="0">
+                <a:solidFill>
+                  <a:srgbClr val="1A1A1A"/>
+                </a:solidFill>
+                <a:latin typeface="Raleway"/>
+              </a:rPr>
+              <a:t>- Emaitzak workspace batean ordenatuta gordetzeko.</a:t>
+            </a:r>
+          </a:p>
+        </p:txBody>
+      </p:sp>
+      <p:sp>
+        <p:nvSpPr>
+          <p:cNvPr id="5" name="TextBox 4"/>
+          <p:cNvSpPr txBox="1"/>
+          <p:nvPr/>
+        </p:nvSpPr>
+        <p:spPr>
+          <a:xfrm>
+            <a:off x="822960" y="2980944"/>
+            <a:ext cx="10515600" cy="777240"/>
+          </a:xfrm>
+          <a:prstGeom prst="rect">
+            <a:avLst/>
+          </a:prstGeom>
+          <a:noFill/>
+        </p:spPr>
+        <p:txBody>
+          <a:bodyPr wrap="square">
+            <a:spAutoFit/>
+          </a:bodyPr>
+          <a:lstStyle/>
+          <a:p>
+            <a:r>
+              <a:rPr sz="2300" b="0" i="0">
+                <a:solidFill>
+                  <a:srgbClr val="1A1A1A"/>
+                </a:solidFill>
+                <a:latin typeface="Raleway"/>
+              </a:rPr>
+              <a:t>- Bilaketak errepikatu eta esportatzeko.</a:t>
             </a:r>
           </a:p>
         </p:txBody>
@@ -3558,7 +3589,7 @@
     <p:bg>
       <p:bgPr>
         <a:solidFill>
-          <a:srgbClr val="0F1419"/>
+          <a:srgbClr val="E9EDEE"/>
         </a:solidFill>
         <a:effectLst/>
       </p:bgPr>
@@ -3578,208 +3609,28 @@
         </p:nvSpPr>
         <p:spPr>
           <a:xfrm>
-            <a:off x="822960" y="640080"/>
-            <a:ext cx="10058400" cy="548640"/>
-          </a:xfrm>
-          <a:prstGeom prst="rect">
-            <a:avLst/>
-          </a:prstGeom>
-          <a:noFill/>
-        </p:spPr>
-        <p:txBody>
-          <a:bodyPr wrap="square">
-            <a:spAutoFit/>
-          </a:bodyPr>
-          <a:lstStyle/>
-          <a:p>
-            <a:r>
-              <a:rPr sz="3600" b="1">
-                <a:solidFill>
-                  <a:srgbClr val="3D9EE5"/>
-                </a:solidFill>
-                <a:latin typeface="Calibri"/>
-              </a:rPr>
-              <a:t>Adibide komandoak</a:t>
-            </a:r>
-          </a:p>
-        </p:txBody>
-      </p:sp>
-      <p:sp>
-        <p:nvSpPr>
-          <p:cNvPr id="3" name="Rounded Rectangle 2"/>
-          <p:cNvSpPr/>
-          <p:nvPr/>
-        </p:nvSpPr>
-        <p:spPr>
-          <a:xfrm>
-            <a:off x="822960" y="1463040"/>
-            <a:ext cx="10241280" cy="4572000"/>
-          </a:xfrm>
-          <a:prstGeom prst="roundRect">
-            <a:avLst/>
-          </a:prstGeom>
-          <a:solidFill>
-            <a:srgbClr val="1A2332"/>
-          </a:solidFill>
-          <a:ln>
-            <a:solidFill>
-              <a:srgbClr val="2A3A4D"/>
-            </a:solidFill>
-          </a:ln>
-        </p:spPr>
-        <p:style>
-          <a:lnRef idx="1">
-            <a:schemeClr val="accent1"/>
-          </a:lnRef>
-          <a:fillRef idx="3">
-            <a:schemeClr val="accent1"/>
-          </a:fillRef>
-          <a:effectRef idx="2">
-            <a:schemeClr val="accent1"/>
-          </a:effectRef>
-          <a:fontRef idx="minor">
-            <a:schemeClr val="lt1"/>
-          </a:fontRef>
-        </p:style>
-        <p:txBody>
-          <a:bodyPr rtlCol="0" anchor="ctr"/>
-          <a:lstStyle/>
-          <a:p>
-            <a:pPr algn="ctr"/>
-          </a:p>
-        </p:txBody>
-      </p:sp>
-      <p:sp>
-        <p:nvSpPr>
-          <p:cNvPr id="4" name="TextBox 3"/>
-          <p:cNvSpPr txBox="1"/>
-          <p:nvPr/>
-        </p:nvSpPr>
-        <p:spPr>
-          <a:xfrm>
-            <a:off x="1097280" y="1691640"/>
-            <a:ext cx="9692640" cy="4206240"/>
-          </a:xfrm>
-          <a:prstGeom prst="rect">
-            <a:avLst/>
-          </a:prstGeom>
-          <a:noFill/>
-        </p:spPr>
-        <p:txBody>
-          <a:bodyPr wrap="square">
-            <a:spAutoFit/>
-          </a:bodyPr>
-          <a:lstStyle/>
-          <a:p>
-            <a:pPr>
-              <a:spcAft>
-                <a:spcPts val="400"/>
-              </a:spcAft>
-            </a:pPr>
-            <a:r>
-              <a:rPr sz="1500">
-                <a:solidFill>
-                  <a:srgbClr val="E8EEF4"/>
-                </a:solidFill>
-                <a:latin typeface="Consolas"/>
-              </a:rPr>
-              <a:t>workspaces create nire_helburua</a:t>
-            </a:r>
-          </a:p>
-          <a:p>
-            <a:pPr>
-              <a:spcAft>
-                <a:spcPts val="400"/>
-              </a:spcAft>
-            </a:pPr>
-            <a:r>
-              <a:rPr sz="1500">
-                <a:solidFill>
-                  <a:srgbClr val="E8EEF4"/>
-                </a:solidFill>
-                <a:latin typeface="Consolas"/>
-              </a:rPr>
-              <a:t>marketplace search hackertarget</a:t>
-            </a:r>
-          </a:p>
-          <a:p>
-            <a:pPr>
-              <a:spcAft>
-                <a:spcPts val="400"/>
-              </a:spcAft>
-            </a:pPr>
-            <a:r>
-              <a:rPr sz="1500">
-                <a:solidFill>
-                  <a:srgbClr val="E8EEF4"/>
-                </a:solidFill>
-                <a:latin typeface="Consolas"/>
-              </a:rPr>
-              <a:t>marketplace install recon/domains-hosts/hackertarget</a:t>
-            </a:r>
-          </a:p>
-          <a:p>
-            <a:pPr>
-              <a:spcAft>
-                <a:spcPts val="400"/>
-              </a:spcAft>
-            </a:pPr>
-            <a:r>
-              <a:rPr sz="1500">
-                <a:solidFill>
-                  <a:srgbClr val="E8EEF4"/>
-                </a:solidFill>
-                <a:latin typeface="Consolas"/>
-              </a:rPr>
-              <a:t>modules load recon/domains-hosts/hackertarget</a:t>
-            </a:r>
-          </a:p>
-          <a:p>
-            <a:pPr>
-              <a:spcAft>
-                <a:spcPts val="400"/>
-              </a:spcAft>
-            </a:pPr>
-            <a:r>
-              <a:rPr sz="1500">
-                <a:solidFill>
-                  <a:srgbClr val="E8EEF4"/>
-                </a:solidFill>
-                <a:latin typeface="Consolas"/>
-              </a:rPr>
-              <a:t>options set SOURCE example.com</a:t>
-            </a:r>
-          </a:p>
-          <a:p>
-            <a:pPr>
-              <a:spcAft>
-                <a:spcPts val="400"/>
-              </a:spcAft>
-            </a:pPr>
-            <a:r>
-              <a:rPr sz="1500">
-                <a:solidFill>
-                  <a:srgbClr val="E8EEF4"/>
-                </a:solidFill>
-                <a:latin typeface="Consolas"/>
-              </a:rPr>
-              <a:t>run</a:t>
-            </a:r>
-          </a:p>
-          <a:p>
-            <a:pPr>
-              <a:spcAft>
-                <a:spcPts val="400"/>
-              </a:spcAft>
-            </a:pPr>
-            <a:r>
-              <a:rPr sz="1500">
-                <a:solidFill>
-                  <a:srgbClr val="E8EEF4"/>
-                </a:solidFill>
-                <a:latin typeface="Consolas"/>
-              </a:rPr>
-              <a:t>show hosts</a:t>
+            <a:off x="822960" y="2743200"/>
+            <a:ext cx="10515600" cy="914400"/>
+          </a:xfrm>
+          <a:prstGeom prst="rect">
+            <a:avLst/>
+          </a:prstGeom>
+          <a:noFill/>
+        </p:spPr>
+        <p:txBody>
+          <a:bodyPr wrap="none">
+            <a:spAutoFit/>
+          </a:bodyPr>
+          <a:lstStyle/>
+          <a:p>
+            <a:r>
+              <a:rPr sz="4200" b="1" i="0">
+                <a:solidFill>
+                  <a:srgbClr val="1A1A1A"/>
+                </a:solidFill>
+                <a:latin typeface="Raleway"/>
+              </a:rPr>
+              <a:t>SpiderFoot</a:t>
             </a:r>
           </a:p>
         </p:txBody>
@@ -3798,7 +3649,7 @@
     <p:bg>
       <p:bgPr>
         <a:solidFill>
-          <a:srgbClr val="0F1419"/>
+          <a:srgbClr val="E9EDEE"/>
         </a:solidFill>
         <a:effectLst/>
       </p:bgPr>
@@ -3818,74 +3669,63 @@
         </p:nvSpPr>
         <p:spPr>
           <a:xfrm>
-            <a:off x="822960" y="914400"/>
-            <a:ext cx="10058400" cy="640080"/>
-          </a:xfrm>
-          <a:prstGeom prst="rect">
-            <a:avLst/>
-          </a:prstGeom>
-          <a:noFill/>
-        </p:spPr>
-        <p:txBody>
-          <a:bodyPr wrap="square">
-            <a:spAutoFit/>
-          </a:bodyPr>
-          <a:lstStyle/>
-          <a:p>
-            <a:r>
-              <a:rPr sz="3600" b="1">
-                <a:solidFill>
-                  <a:srgbClr val="3D9EE5"/>
-                </a:solidFill>
-                <a:latin typeface="Calibri"/>
-              </a:rPr>
-              <a:t>API key recon-ng-n</a:t>
-            </a:r>
-          </a:p>
-        </p:txBody>
-      </p:sp>
-      <p:sp>
-        <p:nvSpPr>
-          <p:cNvPr id="3" name="Rounded Rectangle 2"/>
-          <p:cNvSpPr/>
+            <a:off x="822960" y="822960"/>
+            <a:ext cx="10515600" cy="822960"/>
+          </a:xfrm>
+          <a:prstGeom prst="rect">
+            <a:avLst/>
+          </a:prstGeom>
+          <a:noFill/>
+        </p:spPr>
+        <p:txBody>
+          <a:bodyPr wrap="square">
+            <a:spAutoFit/>
+          </a:bodyPr>
+          <a:lstStyle/>
+          <a:p>
+            <a:r>
+              <a:rPr sz="2400" b="1" i="0">
+                <a:solidFill>
+                  <a:srgbClr val="1A1A1A"/>
+                </a:solidFill>
+                <a:latin typeface="Raleway"/>
+              </a:rPr>
+              <a:t>Zer da SpiderFoot?</a:t>
+            </a:r>
+          </a:p>
+        </p:txBody>
+      </p:sp>
+      <p:sp>
+        <p:nvSpPr>
+          <p:cNvPr id="3" name="TextBox 2"/>
+          <p:cNvSpPr txBox="1"/>
           <p:nvPr/>
         </p:nvSpPr>
         <p:spPr>
           <a:xfrm>
             <a:off x="822960" y="1920240"/>
-            <a:ext cx="10058400" cy="2286000"/>
-          </a:xfrm>
-          <a:prstGeom prst="roundRect">
-            <a:avLst/>
-          </a:prstGeom>
-          <a:solidFill>
-            <a:srgbClr val="1A2332"/>
-          </a:solidFill>
-          <a:ln>
-            <a:solidFill>
-              <a:srgbClr val="2A3A4D"/>
-            </a:solidFill>
-          </a:ln>
-        </p:spPr>
-        <p:style>
-          <a:lnRef idx="1">
-            <a:schemeClr val="accent1"/>
-          </a:lnRef>
-          <a:fillRef idx="3">
-            <a:schemeClr val="accent1"/>
-          </a:fillRef>
-          <a:effectRef idx="2">
-            <a:schemeClr val="accent1"/>
-          </a:effectRef>
-          <a:fontRef idx="minor">
-            <a:schemeClr val="lt1"/>
-          </a:fontRef>
-        </p:style>
-        <p:txBody>
-          <a:bodyPr rtlCol="0" anchor="ctr"/>
-          <a:lstStyle/>
-          <a:p>
-            <a:pPr algn="ctr"/>
+            <a:ext cx="10515600" cy="777240"/>
+          </a:xfrm>
+          <a:prstGeom prst="rect">
+            <a:avLst/>
+          </a:prstGeom>
+          <a:noFill/>
+        </p:spPr>
+        <p:txBody>
+          <a:bodyPr wrap="square">
+            <a:spAutoFit/>
+          </a:bodyPr>
+          <a:lstStyle/>
+          <a:p>
+            <a:r>
+              <a:rPr sz="2300" b="0" i="0">
+                <a:solidFill>
+                  <a:srgbClr val="1A1A1A"/>
+                </a:solidFill>
+                <a:latin typeface="Raleway"/>
+              </a:rPr>
+              <a:t>- OSINT bilaketa automatizatzeko tresna (footprint).</a:t>
+            </a:r>
           </a:p>
         </p:txBody>
       </p:sp>
@@ -3897,65 +3737,28 @@
         </p:nvSpPr>
         <p:spPr>
           <a:xfrm>
-            <a:off x="1097280" y="2148840"/>
-            <a:ext cx="9509760" cy="1920240"/>
-          </a:xfrm>
-          <a:prstGeom prst="rect">
-            <a:avLst/>
-          </a:prstGeom>
-          <a:noFill/>
-        </p:spPr>
-        <p:txBody>
-          <a:bodyPr wrap="square">
-            <a:spAutoFit/>
-          </a:bodyPr>
-          <a:lstStyle/>
-          <a:p>
-            <a:pPr>
-              <a:spcAft>
-                <a:spcPts val="400"/>
-              </a:spcAft>
-            </a:pPr>
-            <a:r>
-              <a:rPr sz="1600">
-                <a:solidFill>
-                  <a:srgbClr val="E8EEF4"/>
-                </a:solidFill>
-                <a:latin typeface="Consolas"/>
-              </a:rPr>
-              <a:t>keys add hunter_io ZURE_API_KEY</a:t>
-            </a:r>
-          </a:p>
-          <a:p>
-            <a:pPr>
-              <a:spcAft>
-                <a:spcPts val="400"/>
-              </a:spcAft>
-            </a:pPr>
-            <a:r>
-              <a:rPr sz="1600">
-                <a:solidFill>
-                  <a:srgbClr val="E8EEF4"/>
-                </a:solidFill>
-                <a:latin typeface="Consolas"/>
-              </a:rPr>
-              <a:t>keys add shodan_api ZURE_API_KEY</a:t>
-            </a:r>
-          </a:p>
-          <a:p>
-            <a:pPr>
-              <a:spcAft>
-                <a:spcPts val="400"/>
-              </a:spcAft>
-            </a:pPr>
-            <a:r>
-              <a:rPr sz="1600">
-                <a:solidFill>
-                  <a:srgbClr val="E8EEF4"/>
-                </a:solidFill>
-                <a:latin typeface="Consolas"/>
-              </a:rPr>
-              <a:t>keys list</a:t>
+            <a:off x="822960" y="2450592"/>
+            <a:ext cx="10515600" cy="777240"/>
+          </a:xfrm>
+          <a:prstGeom prst="rect">
+            <a:avLst/>
+          </a:prstGeom>
+          <a:noFill/>
+        </p:spPr>
+        <p:txBody>
+          <a:bodyPr wrap="square">
+            <a:spAutoFit/>
+          </a:bodyPr>
+          <a:lstStyle/>
+          <a:p>
+            <a:r>
+              <a:rPr sz="2300" b="0" i="0">
+                <a:solidFill>
+                  <a:srgbClr val="1A1A1A"/>
+                </a:solidFill>
+                <a:latin typeface="Raleway"/>
+              </a:rPr>
+              <a:t>- Web interfazearen bidez erabiltzen da.</a:t>
             </a:r>
           </a:p>
         </p:txBody>
@@ -3968,28 +3771,28 @@
         </p:nvSpPr>
         <p:spPr>
           <a:xfrm>
-            <a:off x="822960" y="4572000"/>
-            <a:ext cx="10058400" cy="731520"/>
-          </a:xfrm>
-          <a:prstGeom prst="rect">
-            <a:avLst/>
-          </a:prstGeom>
-          <a:noFill/>
-        </p:spPr>
-        <p:txBody>
-          <a:bodyPr wrap="square">
-            <a:spAutoFit/>
-          </a:bodyPr>
-          <a:lstStyle/>
-          <a:p>
-            <a:r>
-              <a:rPr sz="1800" b="0">
-                <a:solidFill>
-                  <a:srgbClr val="9AABBC"/>
-                </a:solidFill>
-                <a:latin typeface="Calibri"/>
-              </a:rPr>
-              <a:t>Marketplace-n K zutabeak key behar duten moduluak erakusten ditu.</a:t>
+            <a:off x="822960" y="2980944"/>
+            <a:ext cx="10515600" cy="777240"/>
+          </a:xfrm>
+          <a:prstGeom prst="rect">
+            <a:avLst/>
+          </a:prstGeom>
+          <a:noFill/>
+        </p:spPr>
+        <p:txBody>
+          <a:bodyPr wrap="square">
+            <a:spAutoFit/>
+          </a:bodyPr>
+          <a:lstStyle/>
+          <a:p>
+            <a:r>
+              <a:rPr sz="2300" b="0" i="0">
+                <a:solidFill>
+                  <a:srgbClr val="1A1A1A"/>
+                </a:solidFill>
+                <a:latin typeface="Raleway"/>
+              </a:rPr>
+              <a:t>- Kode irekikoa (fork eguneratua GitHub-en).</a:t>
             </a:r>
           </a:p>
         </p:txBody>
@@ -4008,7 +3811,7 @@
     <p:bg>
       <p:bgPr>
         <a:solidFill>
-          <a:srgbClr val="0F1419"/>
+          <a:srgbClr val="E9EDEE"/>
         </a:solidFill>
         <a:effectLst/>
       </p:bgPr>
@@ -4028,28 +3831,28 @@
         </p:nvSpPr>
         <p:spPr>
           <a:xfrm>
-            <a:off x="822960" y="1097280"/>
-            <a:ext cx="10058400" cy="640080"/>
-          </a:xfrm>
-          <a:prstGeom prst="rect">
-            <a:avLst/>
-          </a:prstGeom>
-          <a:noFill/>
-        </p:spPr>
-        <p:txBody>
-          <a:bodyPr wrap="square">
-            <a:spAutoFit/>
-          </a:bodyPr>
-          <a:lstStyle/>
-          <a:p>
-            <a:r>
-              <a:rPr sz="3600" b="1">
-                <a:solidFill>
-                  <a:srgbClr val="3D9EE5"/>
-                </a:solidFill>
-                <a:latin typeface="Calibri"/>
-              </a:rPr>
-              <a:t>Emaitza adibidea (hosts)</a:t>
+            <a:off x="822960" y="822960"/>
+            <a:ext cx="10515600" cy="822960"/>
+          </a:xfrm>
+          <a:prstGeom prst="rect">
+            <a:avLst/>
+          </a:prstGeom>
+          <a:noFill/>
+        </p:spPr>
+        <p:txBody>
+          <a:bodyPr wrap="square">
+            <a:spAutoFit/>
+          </a:bodyPr>
+          <a:lstStyle/>
+          <a:p>
+            <a:r>
+              <a:rPr sz="2400" b="1" i="0">
+                <a:solidFill>
+                  <a:srgbClr val="1A1A1A"/>
+                </a:solidFill>
+                <a:latin typeface="Raleway"/>
+              </a:rPr>
+              <a:t>SpiderFoot — zertarako</a:t>
             </a:r>
           </a:p>
         </p:txBody>
@@ -4062,97 +3865,96 @@
         </p:nvSpPr>
         <p:spPr>
           <a:xfrm>
-            <a:off x="822960" y="2103120"/>
-            <a:ext cx="10058400" cy="3657600"/>
-          </a:xfrm>
-          <a:prstGeom prst="rect">
-            <a:avLst/>
-          </a:prstGeom>
-          <a:noFill/>
-        </p:spPr>
-        <p:txBody>
-          <a:bodyPr wrap="square">
-            <a:spAutoFit/>
-          </a:bodyPr>
-          <a:lstStyle/>
-          <a:p>
-            <a:pPr>
-              <a:spcAft>
-                <a:spcPts val="1400"/>
-              </a:spcAft>
-              <a:defRPr sz="2600">
-                <a:solidFill>
-                  <a:srgbClr val="E8EEF4"/>
-                </a:solidFill>
-                <a:latin typeface="Calibri"/>
-              </a:defRPr>
-            </a:pPr>
-            <a:r>
-              <a:t>show hosts ostean, adibidez:</a:t>
-            </a:r>
-          </a:p>
-          <a:p>
-            <a:pPr>
-              <a:spcAft>
-                <a:spcPts val="1400"/>
-              </a:spcAft>
-              <a:defRPr sz="2600">
-                <a:solidFill>
-                  <a:srgbClr val="E8EEF4"/>
-                </a:solidFill>
-                <a:latin typeface="Calibri"/>
-              </a:defRPr>
-            </a:pPr>
-            <a:r>
-              <a:t>www.example.com → 93.184.216.34</a:t>
-            </a:r>
-          </a:p>
-          <a:p>
-            <a:pPr>
-              <a:spcAft>
-                <a:spcPts val="1400"/>
-              </a:spcAft>
-              <a:defRPr sz="2600">
-                <a:solidFill>
-                  <a:srgbClr val="E8EEF4"/>
-                </a:solidFill>
-                <a:latin typeface="Calibri"/>
-              </a:defRPr>
-            </a:pPr>
-            <a:r>
-              <a:t>mail.example.com → 93.184.216.55</a:t>
-            </a:r>
-          </a:p>
-          <a:p>
-            <a:pPr>
-              <a:spcAft>
-                <a:spcPts val="1400"/>
-              </a:spcAft>
-              <a:defRPr sz="2600">
-                <a:solidFill>
-                  <a:srgbClr val="E8EEF4"/>
-                </a:solidFill>
-                <a:latin typeface="Calibri"/>
-              </a:defRPr>
-            </a:pPr>
-            <a:r>
-              <a:t>blog.example.com → 93.184.216.71</a:t>
-            </a:r>
-          </a:p>
-          <a:p>
-            <a:pPr>
-              <a:spcAft>
-                <a:spcPts val="1400"/>
-              </a:spcAft>
-              <a:defRPr sz="2600">
-                <a:solidFill>
-                  <a:srgbClr val="E8EEF4"/>
-                </a:solidFill>
-                <a:latin typeface="Calibri"/>
-              </a:defRPr>
-            </a:pPr>
-            <a:r>
-              <a:t>Domeinu erreala erabili; emaitzak aldatu egiten dira.</a:t>
+            <a:off x="822960" y="1920240"/>
+            <a:ext cx="10515600" cy="777240"/>
+          </a:xfrm>
+          <a:prstGeom prst="rect">
+            <a:avLst/>
+          </a:prstGeom>
+          <a:noFill/>
+        </p:spPr>
+        <p:txBody>
+          <a:bodyPr wrap="square">
+            <a:spAutoFit/>
+          </a:bodyPr>
+          <a:lstStyle/>
+          <a:p>
+            <a:r>
+              <a:rPr sz="2300" b="0" i="0">
+                <a:solidFill>
+                  <a:srgbClr val="1A1A1A"/>
+                </a:solidFill>
+                <a:latin typeface="Raleway"/>
+              </a:rPr>
+              <a:t>- Helburu baten “footprint” osoa automatikoki biltzeko.</a:t>
+            </a:r>
+          </a:p>
+        </p:txBody>
+      </p:sp>
+      <p:sp>
+        <p:nvSpPr>
+          <p:cNvPr id="4" name="TextBox 3"/>
+          <p:cNvSpPr txBox="1"/>
+          <p:nvPr/>
+        </p:nvSpPr>
+        <p:spPr>
+          <a:xfrm>
+            <a:off x="822960" y="2450592"/>
+            <a:ext cx="10515600" cy="777240"/>
+          </a:xfrm>
+          <a:prstGeom prst="rect">
+            <a:avLst/>
+          </a:prstGeom>
+          <a:noFill/>
+        </p:spPr>
+        <p:txBody>
+          <a:bodyPr wrap="square">
+            <a:spAutoFit/>
+          </a:bodyPr>
+          <a:lstStyle/>
+          <a:p>
+            <a:r>
+              <a:rPr sz="2300" b="0" i="0">
+                <a:solidFill>
+                  <a:srgbClr val="1A1A1A"/>
+                </a:solidFill>
+                <a:latin typeface="Raleway"/>
+              </a:rPr>
+              <a:t>- Modulu asko batera exekutatzeko.</a:t>
+            </a:r>
+          </a:p>
+        </p:txBody>
+      </p:sp>
+      <p:sp>
+        <p:nvSpPr>
+          <p:cNvPr id="5" name="TextBox 4"/>
+          <p:cNvSpPr txBox="1"/>
+          <p:nvPr/>
+        </p:nvSpPr>
+        <p:spPr>
+          <a:xfrm>
+            <a:off x="822960" y="2980944"/>
+            <a:ext cx="10515600" cy="777240"/>
+          </a:xfrm>
+          <a:prstGeom prst="rect">
+            <a:avLst/>
+          </a:prstGeom>
+          <a:noFill/>
+        </p:spPr>
+        <p:txBody>
+          <a:bodyPr wrap="square">
+            <a:spAutoFit/>
+          </a:bodyPr>
+          <a:lstStyle/>
+          <a:p>
+            <a:r>
+              <a:rPr sz="2300" b="0" i="0">
+                <a:solidFill>
+                  <a:srgbClr val="1A1A1A"/>
+                </a:solidFill>
+                <a:latin typeface="Raleway"/>
+              </a:rPr>
+              <a:t>- Emaitzak grafikoan eta txostenetan ikusteko.</a:t>
             </a:r>
           </a:p>
         </p:txBody>
@@ -4171,7 +3973,7 @@
     <p:bg>
       <p:bgPr>
         <a:solidFill>
-          <a:srgbClr val="0F1419"/>
+          <a:srgbClr val="E9EDEE"/>
         </a:solidFill>
         <a:effectLst/>
       </p:bgPr>
@@ -4191,74 +3993,63 @@
         </p:nvSpPr>
         <p:spPr>
           <a:xfrm>
-            <a:off x="822960" y="1097280"/>
-            <a:ext cx="10058400" cy="640080"/>
-          </a:xfrm>
-          <a:prstGeom prst="rect">
-            <a:avLst/>
-          </a:prstGeom>
-          <a:noFill/>
-        </p:spPr>
-        <p:txBody>
-          <a:bodyPr wrap="square">
-            <a:spAutoFit/>
-          </a:bodyPr>
-          <a:lstStyle/>
-          <a:p>
-            <a:r>
-              <a:rPr sz="3600" b="1">
-                <a:solidFill>
-                  <a:srgbClr val="3D9EE5"/>
-                </a:solidFill>
-                <a:latin typeface="Calibri"/>
-              </a:rPr>
-              <a:t>Esportatu</a:t>
-            </a:r>
-          </a:p>
-        </p:txBody>
-      </p:sp>
-      <p:sp>
-        <p:nvSpPr>
-          <p:cNvPr id="3" name="Rounded Rectangle 2"/>
-          <p:cNvSpPr/>
+            <a:off x="822960" y="822960"/>
+            <a:ext cx="10515600" cy="822960"/>
+          </a:xfrm>
+          <a:prstGeom prst="rect">
+            <a:avLst/>
+          </a:prstGeom>
+          <a:noFill/>
+        </p:spPr>
+        <p:txBody>
+          <a:bodyPr wrap="square">
+            <a:spAutoFit/>
+          </a:bodyPr>
+          <a:lstStyle/>
+          <a:p>
+            <a:r>
+              <a:rPr sz="2400" b="1" i="0">
+                <a:solidFill>
+                  <a:srgbClr val="1A1A1A"/>
+                </a:solidFill>
+                <a:latin typeface="Raleway"/>
+              </a:rPr>
+              <a:t>Nola erabiliko dugu guk</a:t>
+            </a:r>
+          </a:p>
+        </p:txBody>
+      </p:sp>
+      <p:sp>
+        <p:nvSpPr>
+          <p:cNvPr id="3" name="TextBox 2"/>
+          <p:cNvSpPr txBox="1"/>
           <p:nvPr/>
         </p:nvSpPr>
         <p:spPr>
           <a:xfrm>
             <a:off x="822960" y="2103120"/>
-            <a:ext cx="10058400" cy="1828800"/>
-          </a:xfrm>
-          <a:prstGeom prst="roundRect">
-            <a:avLst/>
-          </a:prstGeom>
-          <a:solidFill>
-            <a:srgbClr val="1A2332"/>
-          </a:solidFill>
-          <a:ln>
-            <a:solidFill>
-              <a:srgbClr val="2A3A4D"/>
-            </a:solidFill>
-          </a:ln>
-        </p:spPr>
-        <p:style>
-          <a:lnRef idx="1">
-            <a:schemeClr val="accent1"/>
-          </a:lnRef>
-          <a:fillRef idx="3">
-            <a:schemeClr val="accent1"/>
-          </a:fillRef>
-          <a:effectRef idx="2">
-            <a:schemeClr val="accent1"/>
-          </a:effectRef>
-          <a:fontRef idx="minor">
-            <a:schemeClr val="lt1"/>
-          </a:fontRef>
-        </p:style>
-        <p:txBody>
-          <a:bodyPr rtlCol="0" anchor="ctr"/>
-          <a:lstStyle/>
-          <a:p>
-            <a:pPr algn="ctr"/>
+            <a:ext cx="10515600" cy="777240"/>
+          </a:xfrm>
+          <a:prstGeom prst="rect">
+            <a:avLst/>
+          </a:prstGeom>
+          <a:noFill/>
+        </p:spPr>
+        <p:txBody>
+          <a:bodyPr wrap="square">
+            <a:spAutoFit/>
+          </a:bodyPr>
+          <a:lstStyle/>
+          <a:p>
+            <a:r>
+              <a:rPr sz="2300" b="0" i="0">
+                <a:solidFill>
+                  <a:srgbClr val="1A1A1A"/>
+                </a:solidFill>
+                <a:latin typeface="Raleway"/>
+              </a:rPr>
+              <a:t>- recon-ng → Kali Linux-en, komando-lerroa.</a:t>
+            </a:r>
           </a:p>
         </p:txBody>
       </p:sp>
@@ -4270,83 +4061,28 @@
         </p:nvSpPr>
         <p:spPr>
           <a:xfrm>
-            <a:off x="1097280" y="2331720"/>
-            <a:ext cx="9509760" cy="1463040"/>
-          </a:xfrm>
-          <a:prstGeom prst="rect">
-            <a:avLst/>
-          </a:prstGeom>
-          <a:noFill/>
-        </p:spPr>
-        <p:txBody>
-          <a:bodyPr wrap="square">
-            <a:spAutoFit/>
-          </a:bodyPr>
-          <a:lstStyle/>
-          <a:p>
-            <a:pPr>
-              <a:spcAft>
-                <a:spcPts val="400"/>
-              </a:spcAft>
-            </a:pPr>
-            <a:r>
-              <a:rPr sz="1600">
-                <a:solidFill>
-                  <a:srgbClr val="E8EEF4"/>
-                </a:solidFill>
-                <a:latin typeface="Consolas"/>
-              </a:rPr>
-              <a:t>show hosts</a:t>
-            </a:r>
-          </a:p>
-          <a:p>
-            <a:pPr>
-              <a:spcAft>
-                <a:spcPts val="400"/>
-              </a:spcAft>
-            </a:pPr>
-            <a:r>
-              <a:rPr sz="1600">
-                <a:solidFill>
-                  <a:srgbClr val="E8EEF4"/>
-                </a:solidFill>
-                <a:latin typeface="Consolas"/>
-              </a:rPr>
-              <a:t>db export csv hosts.csv</a:t>
-            </a:r>
-          </a:p>
-        </p:txBody>
-      </p:sp>
-      <p:sp>
-        <p:nvSpPr>
-          <p:cNvPr id="5" name="TextBox 4"/>
-          <p:cNvSpPr txBox="1"/>
-          <p:nvPr/>
-        </p:nvSpPr>
-        <p:spPr>
-          <a:xfrm>
-            <a:off x="822960" y="4389120"/>
-            <a:ext cx="10058400" cy="731520"/>
-          </a:xfrm>
-          <a:prstGeom prst="rect">
-            <a:avLst/>
-          </a:prstGeom>
-          <a:noFill/>
-        </p:spPr>
-        <p:txBody>
-          <a:bodyPr wrap="square">
-            <a:spAutoFit/>
-          </a:bodyPr>
-          <a:lstStyle/>
-          <a:p>
-            <a:r>
-              <a:rPr sz="2000" b="0">
-                <a:solidFill>
-                  <a:srgbClr val="9AABBC"/>
-                </a:solidFill>
-                <a:latin typeface="Calibri"/>
-              </a:rPr>
-              <a:t>Emaitzak fitxategira atera eta txostenarekin batera igo.</a:t>
+            <a:off x="822960" y="2633472"/>
+            <a:ext cx="10515600" cy="777240"/>
+          </a:xfrm>
+          <a:prstGeom prst="rect">
+            <a:avLst/>
+          </a:prstGeom>
+          <a:noFill/>
+        </p:spPr>
+        <p:txBody>
+          <a:bodyPr wrap="square">
+            <a:spAutoFit/>
+          </a:bodyPr>
+          <a:lstStyle/>
+          <a:p>
+            <a:r>
+              <a:rPr sz="2300" b="0" i="0">
+                <a:solidFill>
+                  <a:srgbClr val="1A1A1A"/>
+                </a:solidFill>
+                <a:latin typeface="Raleway"/>
+              </a:rPr>
+              <a:t>- SpiderFoot → Docker bidez, web interfazea.</a:t>
             </a:r>
           </a:p>
         </p:txBody>
@@ -4365,7 +4101,7 @@
     <p:bg>
       <p:bgPr>
         <a:solidFill>
-          <a:srgbClr val="0F1419"/>
+          <a:srgbClr val="E9EDEE"/>
         </a:solidFill>
         <a:effectLst/>
       </p:bgPr>
@@ -4385,28 +4121,28 @@
         </p:nvSpPr>
         <p:spPr>
           <a:xfrm>
-            <a:off x="822960" y="2560320"/>
-            <a:ext cx="10058400" cy="914400"/>
-          </a:xfrm>
-          <a:prstGeom prst="rect">
-            <a:avLst/>
-          </a:prstGeom>
-          <a:noFill/>
-        </p:spPr>
-        <p:txBody>
-          <a:bodyPr wrap="square">
-            <a:spAutoFit/>
-          </a:bodyPr>
-          <a:lstStyle/>
-          <a:p>
-            <a:r>
-              <a:rPr sz="4800" b="1">
-                <a:solidFill>
-                  <a:srgbClr val="E8EEF4"/>
-                </a:solidFill>
-                <a:latin typeface="Calibri"/>
-              </a:rPr>
-              <a:t>SpiderFoot</a:t>
+            <a:off x="822960" y="822960"/>
+            <a:ext cx="10515600" cy="822960"/>
+          </a:xfrm>
+          <a:prstGeom prst="rect">
+            <a:avLst/>
+          </a:prstGeom>
+          <a:noFill/>
+        </p:spPr>
+        <p:txBody>
+          <a:bodyPr wrap="square">
+            <a:spAutoFit/>
+          </a:bodyPr>
+          <a:lstStyle/>
+          <a:p>
+            <a:r>
+              <a:rPr sz="2400" b="1" i="0">
+                <a:solidFill>
+                  <a:srgbClr val="1A1A1A"/>
+                </a:solidFill>
+                <a:latin typeface="Raleway"/>
+              </a:rPr>
+              <a:t>Bi tresnak — ideia bera</a:t>
             </a:r>
           </a:p>
         </p:txBody>
@@ -4419,28 +4155,96 @@
         </p:nvSpPr>
         <p:spPr>
           <a:xfrm>
-            <a:off x="822960" y="3657600"/>
-            <a:ext cx="10058400" cy="548640"/>
-          </a:xfrm>
-          <a:prstGeom prst="rect">
-            <a:avLst/>
-          </a:prstGeom>
-          <a:noFill/>
-        </p:spPr>
-        <p:txBody>
-          <a:bodyPr wrap="square">
-            <a:spAutoFit/>
-          </a:bodyPr>
-          <a:lstStyle/>
-          <a:p>
-            <a:r>
-              <a:rPr sz="2600" b="0">
-                <a:solidFill>
-                  <a:srgbClr val="9AABBC"/>
-                </a:solidFill>
-                <a:latin typeface="Calibri"/>
-              </a:rPr>
-              <a:t>OSINT automatizatua — web interfazea</a:t>
+            <a:off x="822960" y="1920240"/>
+            <a:ext cx="10515600" cy="777240"/>
+          </a:xfrm>
+          <a:prstGeom prst="rect">
+            <a:avLst/>
+          </a:prstGeom>
+          <a:noFill/>
+        </p:spPr>
+        <p:txBody>
+          <a:bodyPr wrap="square">
+            <a:spAutoFit/>
+          </a:bodyPr>
+          <a:lstStyle/>
+          <a:p>
+            <a:r>
+              <a:rPr sz="2300" b="0" i="0">
+                <a:solidFill>
+                  <a:srgbClr val="1A1A1A"/>
+                </a:solidFill>
+                <a:latin typeface="Raleway"/>
+              </a:rPr>
+              <a:t>- Iturri publikoetatik informazioa biltzen dute.</a:t>
+            </a:r>
+          </a:p>
+        </p:txBody>
+      </p:sp>
+      <p:sp>
+        <p:nvSpPr>
+          <p:cNvPr id="4" name="TextBox 3"/>
+          <p:cNvSpPr txBox="1"/>
+          <p:nvPr/>
+        </p:nvSpPr>
+        <p:spPr>
+          <a:xfrm>
+            <a:off x="822960" y="2450592"/>
+            <a:ext cx="10515600" cy="777240"/>
+          </a:xfrm>
+          <a:prstGeom prst="rect">
+            <a:avLst/>
+          </a:prstGeom>
+          <a:noFill/>
+        </p:spPr>
+        <p:txBody>
+          <a:bodyPr wrap="square">
+            <a:spAutoFit/>
+          </a:bodyPr>
+          <a:lstStyle/>
+          <a:p>
+            <a:r>
+              <a:rPr sz="2300" b="0" i="0">
+                <a:solidFill>
+                  <a:srgbClr val="1A1A1A"/>
+                </a:solidFill>
+                <a:latin typeface="Raleway"/>
+              </a:rPr>
+              <a:t>- API-en bidez kanpoko zerbitzuak lotzen dituzte.</a:t>
+            </a:r>
+          </a:p>
+        </p:txBody>
+      </p:sp>
+      <p:sp>
+        <p:nvSpPr>
+          <p:cNvPr id="5" name="TextBox 4"/>
+          <p:cNvSpPr txBox="1"/>
+          <p:nvPr/>
+        </p:nvSpPr>
+        <p:spPr>
+          <a:xfrm>
+            <a:off x="822960" y="2980944"/>
+            <a:ext cx="10515600" cy="777240"/>
+          </a:xfrm>
+          <a:prstGeom prst="rect">
+            <a:avLst/>
+          </a:prstGeom>
+          <a:noFill/>
+        </p:spPr>
+        <p:txBody>
+          <a:bodyPr wrap="square">
+            <a:spAutoFit/>
+          </a:bodyPr>
+          <a:lstStyle/>
+          <a:p>
+            <a:r>
+              <a:rPr sz="2300" b="0" i="0">
+                <a:solidFill>
+                  <a:srgbClr val="1A1A1A"/>
+                </a:solidFill>
+                <a:latin typeface="Raleway"/>
+              </a:rPr>
+              <a:t>- Ezagutze pasiborako lagungarriak dira.</a:t>
             </a:r>
           </a:p>
         </p:txBody>
@@ -4459,7 +4263,7 @@
     <p:bg>
       <p:bgPr>
         <a:solidFill>
-          <a:srgbClr val="0F1419"/>
+          <a:srgbClr val="E9EDEE"/>
         </a:solidFill>
         <a:effectLst/>
       </p:bgPr>
@@ -4479,28 +4283,28 @@
         </p:nvSpPr>
         <p:spPr>
           <a:xfrm>
-            <a:off x="822960" y="1097280"/>
-            <a:ext cx="10058400" cy="731520"/>
-          </a:xfrm>
-          <a:prstGeom prst="rect">
-            <a:avLst/>
-          </a:prstGeom>
-          <a:noFill/>
-        </p:spPr>
-        <p:txBody>
-          <a:bodyPr wrap="square">
-            <a:spAutoFit/>
-          </a:bodyPr>
-          <a:lstStyle/>
-          <a:p>
-            <a:r>
-              <a:rPr sz="3600" b="1">
-                <a:solidFill>
-                  <a:srgbClr val="3D9EE5"/>
-                </a:solidFill>
-                <a:latin typeface="Calibri"/>
-              </a:rPr>
-              <a:t>Zer da SpiderFoot?</a:t>
+            <a:off x="822960" y="822960"/>
+            <a:ext cx="10515600" cy="822960"/>
+          </a:xfrm>
+          <a:prstGeom prst="rect">
+            <a:avLst/>
+          </a:prstGeom>
+          <a:noFill/>
+        </p:spPr>
+        <p:txBody>
+          <a:bodyPr wrap="square">
+            <a:spAutoFit/>
+          </a:bodyPr>
+          <a:lstStyle/>
+          <a:p>
+            <a:r>
+              <a:rPr sz="2400" b="1" i="0">
+                <a:solidFill>
+                  <a:srgbClr val="1A1A1A"/>
+                </a:solidFill>
+                <a:latin typeface="Raleway"/>
+              </a:rPr>
+              <a:t>Emaitza adibidea</a:t>
             </a:r>
           </a:p>
         </p:txBody>
@@ -4513,81 +4317,164 @@
         </p:nvSpPr>
         <p:spPr>
           <a:xfrm>
-            <a:off x="822960" y="2194560"/>
-            <a:ext cx="10058400" cy="3657600"/>
-          </a:xfrm>
-          <a:prstGeom prst="rect">
-            <a:avLst/>
-          </a:prstGeom>
-          <a:noFill/>
-        </p:spPr>
-        <p:txBody>
-          <a:bodyPr wrap="square">
-            <a:spAutoFit/>
-          </a:bodyPr>
-          <a:lstStyle/>
-          <a:p>
-            <a:pPr>
-              <a:spcAft>
-                <a:spcPts val="1400"/>
-              </a:spcAft>
-              <a:defRPr sz="2600">
-                <a:solidFill>
-                  <a:srgbClr val="E8EEF4"/>
-                </a:solidFill>
-                <a:latin typeface="Calibri"/>
-              </a:defRPr>
-            </a:pPr>
-            <a:r>
-              <a:t>OSINT bilaketa automatikoa (footprint).</a:t>
-            </a:r>
-          </a:p>
-          <a:p>
-            <a:pPr>
-              <a:spcAft>
-                <a:spcPts val="1400"/>
-              </a:spcAft>
-              <a:defRPr sz="2600">
-                <a:solidFill>
-                  <a:srgbClr val="E8EEF4"/>
-                </a:solidFill>
-                <a:latin typeface="Calibri"/>
-              </a:defRPr>
-            </a:pPr>
-            <a:r>
-              <a:t>2022an Intel 471-ek erosi; kode irekiko fork eguneratua.</a:t>
-            </a:r>
-          </a:p>
-          <a:p>
-            <a:pPr>
-              <a:spcAft>
-                <a:spcPts val="1400"/>
-              </a:spcAft>
-              <a:defRPr sz="2600">
-                <a:solidFill>
-                  <a:srgbClr val="E8EEF4"/>
-                </a:solidFill>
-                <a:latin typeface="Calibri"/>
-              </a:defRPr>
-            </a:pPr>
-            <a:r>
-              <a:t>Web UI batekin erabiltzen da.</a:t>
-            </a:r>
-          </a:p>
-          <a:p>
-            <a:pPr>
-              <a:spcAft>
-                <a:spcPts val="1400"/>
-              </a:spcAft>
-              <a:defRPr sz="2600">
-                <a:solidFill>
-                  <a:srgbClr val="E8EEF4"/>
-                </a:solidFill>
-                <a:latin typeface="Calibri"/>
-              </a:defRPr>
-            </a:pPr>
-            <a:r>
-              <a:t>https://github.com/poppopjmp/spiderfoot</a:t>
+            <a:off x="822960" y="1828800"/>
+            <a:ext cx="10515600" cy="777240"/>
+          </a:xfrm>
+          <a:prstGeom prst="rect">
+            <a:avLst/>
+          </a:prstGeom>
+          <a:noFill/>
+        </p:spPr>
+        <p:txBody>
+          <a:bodyPr wrap="square">
+            <a:spAutoFit/>
+          </a:bodyPr>
+          <a:lstStyle/>
+          <a:p>
+            <a:r>
+              <a:rPr sz="2300" b="0" i="0">
+                <a:solidFill>
+                  <a:srgbClr val="1A1A1A"/>
+                </a:solidFill>
+                <a:latin typeface="Raleway"/>
+              </a:rPr>
+              <a:t>Helburua: example.com</a:t>
+            </a:r>
+          </a:p>
+        </p:txBody>
+      </p:sp>
+      <p:sp>
+        <p:nvSpPr>
+          <p:cNvPr id="4" name="TextBox 3"/>
+          <p:cNvSpPr txBox="1"/>
+          <p:nvPr/>
+        </p:nvSpPr>
+        <p:spPr>
+          <a:xfrm>
+            <a:off x="822960" y="2359152"/>
+            <a:ext cx="10515600" cy="777240"/>
+          </a:xfrm>
+          <a:prstGeom prst="rect">
+            <a:avLst/>
+          </a:prstGeom>
+          <a:noFill/>
+        </p:spPr>
+        <p:txBody>
+          <a:bodyPr wrap="square">
+            <a:spAutoFit/>
+          </a:bodyPr>
+          <a:lstStyle/>
+          <a:p>
+            <a:r>
+              <a:rPr sz="2300" b="0" i="0">
+                <a:solidFill>
+                  <a:srgbClr val="1A1A1A"/>
+                </a:solidFill>
+                <a:latin typeface="Raleway"/>
+              </a:rPr>
+              <a:t/>
+            </a:r>
+          </a:p>
+        </p:txBody>
+      </p:sp>
+      <p:sp>
+        <p:nvSpPr>
+          <p:cNvPr id="5" name="TextBox 4"/>
+          <p:cNvSpPr txBox="1"/>
+          <p:nvPr/>
+        </p:nvSpPr>
+        <p:spPr>
+          <a:xfrm>
+            <a:off x="822960" y="2889504"/>
+            <a:ext cx="10515600" cy="777240"/>
+          </a:xfrm>
+          <a:prstGeom prst="rect">
+            <a:avLst/>
+          </a:prstGeom>
+          <a:noFill/>
+        </p:spPr>
+        <p:txBody>
+          <a:bodyPr wrap="square">
+            <a:spAutoFit/>
+          </a:bodyPr>
+          <a:lstStyle/>
+          <a:p>
+            <a:r>
+              <a:rPr sz="2300" b="0" i="0">
+                <a:solidFill>
+                  <a:srgbClr val="1A1A1A"/>
+                </a:solidFill>
+                <a:latin typeface="Raleway"/>
+              </a:rPr>
+              <a:t>- Azpidomeinuak: www, mail, blog…</a:t>
+            </a:r>
+          </a:p>
+        </p:txBody>
+      </p:sp>
+      <p:sp>
+        <p:nvSpPr>
+          <p:cNvPr id="6" name="TextBox 5"/>
+          <p:cNvSpPr txBox="1"/>
+          <p:nvPr/>
+        </p:nvSpPr>
+        <p:spPr>
+          <a:xfrm>
+            <a:off x="822960" y="3419856"/>
+            <a:ext cx="10515600" cy="777240"/>
+          </a:xfrm>
+          <a:prstGeom prst="rect">
+            <a:avLst/>
+          </a:prstGeom>
+          <a:noFill/>
+        </p:spPr>
+        <p:txBody>
+          <a:bodyPr wrap="square">
+            <a:spAutoFit/>
+          </a:bodyPr>
+          <a:lstStyle/>
+          <a:p>
+            <a:r>
+              <a:rPr sz="2300" b="0" i="0">
+                <a:solidFill>
+                  <a:srgbClr val="1A1A1A"/>
+                </a:solidFill>
+                <a:latin typeface="Raleway"/>
+              </a:rPr>
+              <a:t>- Korreoak: info@example.com…</a:t>
+            </a:r>
+          </a:p>
+        </p:txBody>
+      </p:sp>
+      <p:sp>
+        <p:nvSpPr>
+          <p:cNvPr id="7" name="TextBox 6"/>
+          <p:cNvSpPr txBox="1"/>
+          <p:nvPr/>
+        </p:nvSpPr>
+        <p:spPr>
+          <a:xfrm>
+            <a:off x="822960" y="3950208"/>
+            <a:ext cx="10515600" cy="777240"/>
+          </a:xfrm>
+          <a:prstGeom prst="rect">
+            <a:avLst/>
+          </a:prstGeom>
+          <a:noFill/>
+        </p:spPr>
+        <p:txBody>
+          <a:bodyPr wrap="square">
+            <a:spAutoFit/>
+          </a:bodyPr>
+          <a:lstStyle/>
+          <a:p>
+            <a:r>
+              <a:rPr sz="2300" b="0" i="0">
+                <a:solidFill>
+                  <a:srgbClr val="1A1A1A"/>
+                </a:solidFill>
+                <a:latin typeface="Raleway"/>
+              </a:rPr>
+              <a:t>- IP / DNS loturak</a:t>
             </a:r>
           </a:p>
         </p:txBody>
@@ -4606,7 +4493,7 @@
     <p:bg>
       <p:bgPr>
         <a:solidFill>
-          <a:srgbClr val="0F1419"/>
+          <a:srgbClr val="E9EDEE"/>
         </a:solidFill>
         <a:effectLst/>
       </p:bgPr>
@@ -4626,28 +4513,28 @@
         </p:nvSpPr>
         <p:spPr>
           <a:xfrm>
-            <a:off x="822960" y="1097280"/>
-            <a:ext cx="10058400" cy="731520"/>
-          </a:xfrm>
-          <a:prstGeom prst="rect">
-            <a:avLst/>
-          </a:prstGeom>
-          <a:noFill/>
-        </p:spPr>
-        <p:txBody>
-          <a:bodyPr wrap="square">
-            <a:spAutoFit/>
-          </a:bodyPr>
-          <a:lstStyle/>
-          <a:p>
-            <a:r>
-              <a:rPr sz="3600" b="1">
-                <a:solidFill>
-                  <a:srgbClr val="3D9EE5"/>
-                </a:solidFill>
-                <a:latin typeface="Calibri"/>
-              </a:rPr>
-              <a:t>Instalazioa: Docker</a:t>
+            <a:off x="822960" y="822960"/>
+            <a:ext cx="10515600" cy="822960"/>
+          </a:xfrm>
+          <a:prstGeom prst="rect">
+            <a:avLst/>
+          </a:prstGeom>
+          <a:noFill/>
+        </p:spPr>
+        <p:txBody>
+          <a:bodyPr wrap="square">
+            <a:spAutoFit/>
+          </a:bodyPr>
+          <a:lstStyle/>
+          <a:p>
+            <a:r>
+              <a:rPr sz="2400" b="1" i="0">
+                <a:solidFill>
+                  <a:srgbClr val="1A1A1A"/>
+                </a:solidFill>
+                <a:latin typeface="Raleway"/>
+              </a:rPr>
+              <a:t>Praktikarako gogorarazpena</a:t>
             </a:r>
           </a:p>
         </p:txBody>
@@ -4660,65 +4547,96 @@
         </p:nvSpPr>
         <p:spPr>
           <a:xfrm>
-            <a:off x="822960" y="2194560"/>
-            <a:ext cx="10058400" cy="3657600"/>
-          </a:xfrm>
-          <a:prstGeom prst="rect">
-            <a:avLst/>
-          </a:prstGeom>
-          <a:noFill/>
-        </p:spPr>
-        <p:txBody>
-          <a:bodyPr wrap="square">
-            <a:spAutoFit/>
-          </a:bodyPr>
-          <a:lstStyle/>
-          <a:p>
-            <a:pPr>
-              <a:spcAft>
-                <a:spcPts val="1400"/>
-              </a:spcAft>
-              <a:defRPr sz="2600">
-                <a:solidFill>
-                  <a:srgbClr val="E8EEF4"/>
-                </a:solidFill>
-                <a:latin typeface="Calibri"/>
-              </a:defRPr>
-            </a:pPr>
-            <a:r>
-              <a:t>Klasean Docker erabiliko dugu.</a:t>
-            </a:r>
-          </a:p>
-          <a:p>
-            <a:pPr>
-              <a:spcAft>
-                <a:spcPts val="1400"/>
-              </a:spcAft>
-              <a:defRPr sz="2600">
-                <a:solidFill>
-                  <a:srgbClr val="E8EEF4"/>
-                </a:solidFill>
-                <a:latin typeface="Calibri"/>
-              </a:defRPr>
-            </a:pPr>
-            <a:r>
-              <a:t>Dokumentazio ofizialaren urratsak jarraitu.</a:t>
-            </a:r>
-          </a:p>
-          <a:p>
-            <a:pPr>
-              <a:spcAft>
-                <a:spcPts val="1400"/>
-              </a:spcAft>
-              <a:defRPr sz="2600">
-                <a:solidFill>
-                  <a:srgbClr val="E8EEF4"/>
-                </a:solidFill>
-                <a:latin typeface="Calibri"/>
-              </a:defRPr>
-            </a:pPr>
-            <a:r>
-              <a:t>Abiarazi ostean: nabigatzailean web interfazea.</a:t>
+            <a:off x="822960" y="1920240"/>
+            <a:ext cx="10515600" cy="777240"/>
+          </a:xfrm>
+          <a:prstGeom prst="rect">
+            <a:avLst/>
+          </a:prstGeom>
+          <a:noFill/>
+        </p:spPr>
+        <p:txBody>
+          <a:bodyPr wrap="square">
+            <a:spAutoFit/>
+          </a:bodyPr>
+          <a:lstStyle/>
+          <a:p>
+            <a:r>
+              <a:rPr sz="2300" b="0" i="0">
+                <a:solidFill>
+                  <a:srgbClr val="1A1A1A"/>
+                </a:solidFill>
+                <a:latin typeface="Raleway"/>
+              </a:rPr>
+              <a:t>- Helburu propioak edo baimenduak soilik.</a:t>
+            </a:r>
+          </a:p>
+        </p:txBody>
+      </p:sp>
+      <p:sp>
+        <p:nvSpPr>
+          <p:cNvPr id="4" name="TextBox 3"/>
+          <p:cNvSpPr txBox="1"/>
+          <p:nvPr/>
+        </p:nvSpPr>
+        <p:spPr>
+          <a:xfrm>
+            <a:off x="822960" y="2450592"/>
+            <a:ext cx="10515600" cy="777240"/>
+          </a:xfrm>
+          <a:prstGeom prst="rect">
+            <a:avLst/>
+          </a:prstGeom>
+          <a:noFill/>
+        </p:spPr>
+        <p:txBody>
+          <a:bodyPr wrap="square">
+            <a:spAutoFit/>
+          </a:bodyPr>
+          <a:lstStyle/>
+          <a:p>
+            <a:r>
+              <a:rPr sz="2300" b="0" i="0">
+                <a:solidFill>
+                  <a:srgbClr val="1A1A1A"/>
+                </a:solidFill>
+                <a:latin typeface="Raleway"/>
+              </a:rPr>
+              <a:t>- Iturri publikoak eta legezkoak.</a:t>
+            </a:r>
+          </a:p>
+        </p:txBody>
+      </p:sp>
+      <p:sp>
+        <p:nvSpPr>
+          <p:cNvPr id="5" name="TextBox 4"/>
+          <p:cNvSpPr txBox="1"/>
+          <p:nvPr/>
+        </p:nvSpPr>
+        <p:spPr>
+          <a:xfrm>
+            <a:off x="822960" y="2980944"/>
+            <a:ext cx="10515600" cy="777240"/>
+          </a:xfrm>
+          <a:prstGeom prst="rect">
+            <a:avLst/>
+          </a:prstGeom>
+          <a:noFill/>
+        </p:spPr>
+        <p:txBody>
+          <a:bodyPr wrap="square">
+            <a:spAutoFit/>
+          </a:bodyPr>
+          <a:lstStyle/>
+          <a:p>
+            <a:r>
+              <a:rPr sz="2300" b="0" i="0">
+                <a:solidFill>
+                  <a:srgbClr val="1A1A1A"/>
+                </a:solidFill>
+                <a:latin typeface="Raleway"/>
+              </a:rPr>
+              <a:t>- API key gabe emaitza gutxi → erregistratu edo beste modulu.</a:t>
             </a:r>
           </a:p>
         </p:txBody>
@@ -4737,7 +4655,7 @@
     <p:bg>
       <p:bgPr>
         <a:solidFill>
-          <a:srgbClr val="0F1419"/>
+          <a:srgbClr val="E9EDEE"/>
         </a:solidFill>
         <a:effectLst/>
       </p:bgPr>
@@ -4757,74 +4675,63 @@
         </p:nvSpPr>
         <p:spPr>
           <a:xfrm>
-            <a:off x="822960" y="914400"/>
-            <a:ext cx="10058400" cy="640080"/>
-          </a:xfrm>
-          <a:prstGeom prst="rect">
-            <a:avLst/>
-          </a:prstGeom>
-          <a:noFill/>
-        </p:spPr>
-        <p:txBody>
-          <a:bodyPr wrap="square">
-            <a:spAutoFit/>
-          </a:bodyPr>
-          <a:lstStyle/>
-          <a:p>
-            <a:r>
-              <a:rPr sz="3600" b="1">
-                <a:solidFill>
-                  <a:srgbClr val="3D9EE5"/>
-                </a:solidFill>
-                <a:latin typeface="Calibri"/>
-              </a:rPr>
-              <a:t>Docker adibidea</a:t>
-            </a:r>
-          </a:p>
-        </p:txBody>
-      </p:sp>
-      <p:sp>
-        <p:nvSpPr>
-          <p:cNvPr id="3" name="Rounded Rectangle 2"/>
-          <p:cNvSpPr/>
+            <a:off x="822960" y="822960"/>
+            <a:ext cx="10515600" cy="822960"/>
+          </a:xfrm>
+          <a:prstGeom prst="rect">
+            <a:avLst/>
+          </a:prstGeom>
+          <a:noFill/>
+        </p:spPr>
+        <p:txBody>
+          <a:bodyPr wrap="square">
+            <a:spAutoFit/>
+          </a:bodyPr>
+          <a:lstStyle/>
+          <a:p>
+            <a:r>
+              <a:rPr sz="2400" b="1" i="0">
+                <a:solidFill>
+                  <a:srgbClr val="1A1A1A"/>
+                </a:solidFill>
+                <a:latin typeface="Raleway"/>
+              </a:rPr>
+              <a:t>Entrega</a:t>
+            </a:r>
+          </a:p>
+        </p:txBody>
+      </p:sp>
+      <p:sp>
+        <p:nvSpPr>
+          <p:cNvPr id="3" name="TextBox 2"/>
+          <p:cNvSpPr txBox="1"/>
           <p:nvPr/>
         </p:nvSpPr>
         <p:spPr>
           <a:xfrm>
             <a:off x="822960" y="1920240"/>
-            <a:ext cx="10058400" cy="2194560"/>
-          </a:xfrm>
-          <a:prstGeom prst="roundRect">
-            <a:avLst/>
-          </a:prstGeom>
-          <a:solidFill>
-            <a:srgbClr val="1A2332"/>
-          </a:solidFill>
-          <a:ln>
-            <a:solidFill>
-              <a:srgbClr val="2A3A4D"/>
-            </a:solidFill>
-          </a:ln>
-        </p:spPr>
-        <p:style>
-          <a:lnRef idx="1">
-            <a:schemeClr val="accent1"/>
-          </a:lnRef>
-          <a:fillRef idx="3">
-            <a:schemeClr val="accent1"/>
-          </a:fillRef>
-          <a:effectRef idx="2">
-            <a:schemeClr val="accent1"/>
-          </a:effectRef>
-          <a:fontRef idx="minor">
-            <a:schemeClr val="lt1"/>
-          </a:fontRef>
-        </p:style>
-        <p:txBody>
-          <a:bodyPr rtlCol="0" anchor="ctr"/>
-          <a:lstStyle/>
-          <a:p>
-            <a:pPr algn="ctr"/>
+            <a:ext cx="10515600" cy="777240"/>
+          </a:xfrm>
+          <a:prstGeom prst="rect">
+            <a:avLst/>
+          </a:prstGeom>
+          <a:noFill/>
+        </p:spPr>
+        <p:txBody>
+          <a:bodyPr wrap="square">
+            <a:spAutoFit/>
+          </a:bodyPr>
+          <a:lstStyle/>
+          <a:p>
+            <a:r>
+              <a:rPr sz="2300" b="0" i="0">
+                <a:solidFill>
+                  <a:srgbClr val="1A1A1A"/>
+                </a:solidFill>
+                <a:latin typeface="Raleway"/>
+              </a:rPr>
+              <a:t>- Dokumentua: urratsak + lortutako informazioa.</a:t>
+            </a:r>
           </a:p>
         </p:txBody>
       </p:sp>
@@ -4836,49 +4743,28 @@
         </p:nvSpPr>
         <p:spPr>
           <a:xfrm>
-            <a:off x="1097280" y="2148840"/>
-            <a:ext cx="9509760" cy="1828800"/>
-          </a:xfrm>
-          <a:prstGeom prst="rect">
-            <a:avLst/>
-          </a:prstGeom>
-          <a:noFill/>
-        </p:spPr>
-        <p:txBody>
-          <a:bodyPr wrap="square">
-            <a:spAutoFit/>
-          </a:bodyPr>
-          <a:lstStyle/>
-          <a:p>
-            <a:pPr>
-              <a:spcAft>
-                <a:spcPts val="400"/>
-              </a:spcAft>
-            </a:pPr>
-            <a:r>
-              <a:rPr sz="1600">
-                <a:solidFill>
-                  <a:srgbClr val="E8EEF4"/>
-                </a:solidFill>
-                <a:latin typeface="Consolas"/>
-              </a:rPr>
-              <a:t>docker pull poppopjmp/spiderfoot</a:t>
-            </a:r>
-          </a:p>
-          <a:p>
-            <a:pPr>
-              <a:spcAft>
-                <a:spcPts val="400"/>
-              </a:spcAft>
-            </a:pPr>
-            <a:r>
-              <a:rPr sz="1600">
-                <a:solidFill>
-                  <a:srgbClr val="E8EEF4"/>
-                </a:solidFill>
-                <a:latin typeface="Consolas"/>
-              </a:rPr>
-              <a:t>docker run -p 5001:5001 poppopjmp/spiderfoot</a:t>
+            <a:off x="822960" y="2450592"/>
+            <a:ext cx="10515600" cy="777240"/>
+          </a:xfrm>
+          <a:prstGeom prst="rect">
+            <a:avLst/>
+          </a:prstGeom>
+          <a:noFill/>
+        </p:spPr>
+        <p:txBody>
+          <a:bodyPr wrap="square">
+            <a:spAutoFit/>
+          </a:bodyPr>
+          <a:lstStyle/>
+          <a:p>
+            <a:r>
+              <a:rPr sz="2300" b="0" i="0">
+                <a:solidFill>
+                  <a:srgbClr val="1A1A1A"/>
+                </a:solidFill>
+                <a:latin typeface="Raleway"/>
+              </a:rPr>
+              <a:t>- Pantaila-argazkiak.</a:t>
             </a:r>
           </a:p>
         </p:txBody>
@@ -4891,28 +4777,28 @@
         </p:nvSpPr>
         <p:spPr>
           <a:xfrm>
-            <a:off x="822960" y="4572000"/>
-            <a:ext cx="10058400" cy="731520"/>
-          </a:xfrm>
-          <a:prstGeom prst="rect">
-            <a:avLst/>
-          </a:prstGeom>
-          <a:noFill/>
-        </p:spPr>
-        <p:txBody>
-          <a:bodyPr wrap="square">
-            <a:spAutoFit/>
-          </a:bodyPr>
-          <a:lstStyle/>
-          <a:p>
-            <a:r>
-              <a:rPr sz="1800" b="0">
-                <a:solidFill>
-                  <a:srgbClr val="9AABBC"/>
-                </a:solidFill>
-                <a:latin typeface="Calibri"/>
-              </a:rPr>
-              <a:t>Nabigatzailea: http://127.0.0.1:5001  (irudia dokumentazioan egiaztatu)</a:t>
+            <a:off x="822960" y="2980944"/>
+            <a:ext cx="10515600" cy="777240"/>
+          </a:xfrm>
+          <a:prstGeom prst="rect">
+            <a:avLst/>
+          </a:prstGeom>
+          <a:noFill/>
+        </p:spPr>
+        <p:txBody>
+          <a:bodyPr wrap="square">
+            <a:spAutoFit/>
+          </a:bodyPr>
+          <a:lstStyle/>
+          <a:p>
+            <a:r>
+              <a:rPr sz="2300" b="0" i="0">
+                <a:solidFill>
+                  <a:srgbClr val="1A1A1A"/>
+                </a:solidFill>
+                <a:latin typeface="Raleway"/>
+              </a:rPr>
+              <a:t>- Esportazioak erantsi, aukera badago.</a:t>
             </a:r>
           </a:p>
         </p:txBody>
@@ -4931,7 +4817,7 @@
     <p:bg>
       <p:bgPr>
         <a:solidFill>
-          <a:srgbClr val="0F1419"/>
+          <a:srgbClr val="E9EDEE"/>
         </a:solidFill>
         <a:effectLst/>
       </p:bgPr>
@@ -4951,28 +4837,28 @@
         </p:nvSpPr>
         <p:spPr>
           <a:xfrm>
-            <a:off x="822960" y="1097280"/>
-            <a:ext cx="10058400" cy="731520"/>
-          </a:xfrm>
-          <a:prstGeom prst="rect">
-            <a:avLst/>
-          </a:prstGeom>
-          <a:noFill/>
-        </p:spPr>
-        <p:txBody>
-          <a:bodyPr wrap="square">
-            <a:spAutoFit/>
-          </a:bodyPr>
-          <a:lstStyle/>
-          <a:p>
-            <a:r>
-              <a:rPr sz="3600" b="1">
-                <a:solidFill>
-                  <a:srgbClr val="3D9EE5"/>
-                </a:solidFill>
-                <a:latin typeface="Calibri"/>
-              </a:rPr>
-              <a:t>Testuingurua</a:t>
+            <a:off x="822960" y="822960"/>
+            <a:ext cx="10515600" cy="822960"/>
+          </a:xfrm>
+          <a:prstGeom prst="rect">
+            <a:avLst/>
+          </a:prstGeom>
+          <a:noFill/>
+        </p:spPr>
+        <p:txBody>
+          <a:bodyPr wrap="square">
+            <a:spAutoFit/>
+          </a:bodyPr>
+          <a:lstStyle/>
+          <a:p>
+            <a:r>
+              <a:rPr sz="2400" b="1" i="0">
+                <a:solidFill>
+                  <a:srgbClr val="1A1A1A"/>
+                </a:solidFill>
+                <a:latin typeface="Raleway"/>
+              </a:rPr>
+              <a:t>Gaurko gaia</a:t>
             </a:r>
           </a:p>
         </p:txBody>
@@ -4985,65 +4871,96 @@
         </p:nvSpPr>
         <p:spPr>
           <a:xfrm>
-            <a:off x="822960" y="2194560"/>
-            <a:ext cx="10058400" cy="3657600"/>
-          </a:xfrm>
-          <a:prstGeom prst="rect">
-            <a:avLst/>
-          </a:prstGeom>
-          <a:noFill/>
-        </p:spPr>
-        <p:txBody>
-          <a:bodyPr wrap="square">
-            <a:spAutoFit/>
-          </a:bodyPr>
-          <a:lstStyle/>
-          <a:p>
-            <a:pPr>
-              <a:spcAft>
-                <a:spcPts val="1400"/>
-              </a:spcAft>
-              <a:defRPr sz="2600">
-                <a:solidFill>
-                  <a:srgbClr val="E8EEF4"/>
-                </a:solidFill>
-                <a:latin typeface="Calibri"/>
-              </a:defRPr>
-            </a:pPr>
-            <a:r>
-              <a:t>Ezagutze fasean informazio publikoa biltzen dugu (OSINT).</a:t>
-            </a:r>
-          </a:p>
-          <a:p>
-            <a:pPr>
-              <a:spcAft>
-                <a:spcPts val="1400"/>
-              </a:spcAft>
-              <a:defRPr sz="2600">
-                <a:solidFill>
-                  <a:srgbClr val="E8EEF4"/>
-                </a:solidFill>
-                <a:latin typeface="Calibri"/>
-              </a:defRPr>
-            </a:pPr>
-            <a:r>
-              <a:t>Lan errepikakorrak automatizatu daitezke.</a:t>
-            </a:r>
-          </a:p>
-          <a:p>
-            <a:pPr>
-              <a:spcAft>
-                <a:spcPts val="1400"/>
-              </a:spcAft>
-              <a:defRPr sz="2600">
-                <a:solidFill>
-                  <a:srgbClr val="E8EEF4"/>
-                </a:solidFill>
-                <a:latin typeface="Calibri"/>
-              </a:defRPr>
-            </a:pPr>
-            <a:r>
-              <a:t>Gaur: komando-lerroko / web tresna bi.</a:t>
+            <a:off x="822960" y="1920240"/>
+            <a:ext cx="10515600" cy="777240"/>
+          </a:xfrm>
+          <a:prstGeom prst="rect">
+            <a:avLst/>
+          </a:prstGeom>
+          <a:noFill/>
+        </p:spPr>
+        <p:txBody>
+          <a:bodyPr wrap="square">
+            <a:spAutoFit/>
+          </a:bodyPr>
+          <a:lstStyle/>
+          <a:p>
+            <a:r>
+              <a:rPr sz="2300" b="0" i="0">
+                <a:solidFill>
+                  <a:srgbClr val="1A1A1A"/>
+                </a:solidFill>
+                <a:latin typeface="Raleway"/>
+              </a:rPr>
+              <a:t>- Informazioa lortzeko tresna automatizatuak.</a:t>
+            </a:r>
+          </a:p>
+        </p:txBody>
+      </p:sp>
+      <p:sp>
+        <p:nvSpPr>
+          <p:cNvPr id="4" name="TextBox 3"/>
+          <p:cNvSpPr txBox="1"/>
+          <p:nvPr/>
+        </p:nvSpPr>
+        <p:spPr>
+          <a:xfrm>
+            <a:off x="822960" y="2450592"/>
+            <a:ext cx="10515600" cy="777240"/>
+          </a:xfrm>
+          <a:prstGeom prst="rect">
+            <a:avLst/>
+          </a:prstGeom>
+          <a:noFill/>
+        </p:spPr>
+        <p:txBody>
+          <a:bodyPr wrap="square">
+            <a:spAutoFit/>
+          </a:bodyPr>
+          <a:lstStyle/>
+          <a:p>
+            <a:r>
+              <a:rPr sz="2300" b="0" i="0">
+                <a:solidFill>
+                  <a:srgbClr val="1A1A1A"/>
+                </a:solidFill>
+                <a:latin typeface="Raleway"/>
+              </a:rPr>
+              <a:t>- Komando-lerroa (recon-ng) eta web interfazea (SpiderFoot).</a:t>
+            </a:r>
+          </a:p>
+        </p:txBody>
+      </p:sp>
+      <p:sp>
+        <p:nvSpPr>
+          <p:cNvPr id="5" name="TextBox 4"/>
+          <p:cNvSpPr txBox="1"/>
+          <p:nvPr/>
+        </p:nvSpPr>
+        <p:spPr>
+          <a:xfrm>
+            <a:off x="822960" y="2980944"/>
+            <a:ext cx="10515600" cy="777240"/>
+          </a:xfrm>
+          <a:prstGeom prst="rect">
+            <a:avLst/>
+          </a:prstGeom>
+          <a:noFill/>
+        </p:spPr>
+        <p:txBody>
+          <a:bodyPr wrap="square">
+            <a:spAutoFit/>
+          </a:bodyPr>
+          <a:lstStyle/>
+          <a:p>
+            <a:r>
+              <a:rPr sz="2300" b="0" i="0">
+                <a:solidFill>
+                  <a:srgbClr val="1A1A1A"/>
+                </a:solidFill>
+                <a:latin typeface="Raleway"/>
+              </a:rPr>
+              <a:t>- Kali Linux-en lan egingo dugu.</a:t>
             </a:r>
           </a:p>
         </p:txBody>
@@ -5062,7 +4979,7 @@
     <p:bg>
       <p:bgPr>
         <a:solidFill>
-          <a:srgbClr val="0F1419"/>
+          <a:srgbClr val="E9EDEE"/>
         </a:solidFill>
         <a:effectLst/>
       </p:bgPr>
@@ -5082,634 +4999,28 @@
         </p:nvSpPr>
         <p:spPr>
           <a:xfrm>
-            <a:off x="822960" y="1097280"/>
-            <a:ext cx="10058400" cy="731520"/>
-          </a:xfrm>
-          <a:prstGeom prst="rect">
-            <a:avLst/>
-          </a:prstGeom>
-          <a:noFill/>
-        </p:spPr>
-        <p:txBody>
-          <a:bodyPr wrap="square">
-            <a:spAutoFit/>
-          </a:bodyPr>
-          <a:lstStyle/>
-          <a:p>
-            <a:r>
-              <a:rPr sz="3600" b="1">
-                <a:solidFill>
-                  <a:srgbClr val="3D9EE5"/>
-                </a:solidFill>
-                <a:latin typeface="Calibri"/>
-              </a:rPr>
-              <a:t>Zeregina SpiderFoot-ekin</a:t>
-            </a:r>
-          </a:p>
-        </p:txBody>
-      </p:sp>
-      <p:sp>
-        <p:nvSpPr>
-          <p:cNvPr id="3" name="TextBox 2"/>
-          <p:cNvSpPr txBox="1"/>
-          <p:nvPr/>
-        </p:nvSpPr>
-        <p:spPr>
-          <a:xfrm>
-            <a:off x="822960" y="2194560"/>
-            <a:ext cx="10058400" cy="3657600"/>
-          </a:xfrm>
-          <a:prstGeom prst="rect">
-            <a:avLst/>
-          </a:prstGeom>
-          <a:noFill/>
-        </p:spPr>
-        <p:txBody>
-          <a:bodyPr wrap="square">
-            <a:spAutoFit/>
-          </a:bodyPr>
-          <a:lstStyle/>
-          <a:p>
-            <a:pPr>
-              <a:spcAft>
-                <a:spcPts val="1400"/>
-              </a:spcAft>
-              <a:defRPr sz="2600">
-                <a:solidFill>
-                  <a:srgbClr val="E8EEF4"/>
-                </a:solidFill>
-                <a:latin typeface="Calibri"/>
-              </a:defRPr>
-            </a:pPr>
-            <a:r>
-              <a:t>Footprint eskaneo bat domeinuaren gainean</a:t>
-            </a:r>
-          </a:p>
-          <a:p>
-            <a:pPr>
-              <a:spcAft>
-                <a:spcPts val="1400"/>
-              </a:spcAft>
-              <a:defRPr sz="2600">
-                <a:solidFill>
-                  <a:srgbClr val="E8EEF4"/>
-                </a:solidFill>
-                <a:latin typeface="Calibri"/>
-              </a:defRPr>
-            </a:pPr>
-            <a:r>
-              <a:t>hunter.io API key konfiguratu</a:t>
-            </a:r>
-          </a:p>
-          <a:p>
-            <a:pPr>
-              <a:spcAft>
-                <a:spcPts val="1400"/>
-              </a:spcAft>
-              <a:defRPr sz="2600">
-                <a:solidFill>
-                  <a:srgbClr val="E8EEF4"/>
-                </a:solidFill>
-                <a:latin typeface="Calibri"/>
-              </a:defRPr>
-            </a:pPr>
-            <a:r>
-              <a:t>Moduluak ikusi + beste zerbitzu batean erregistratu</a:t>
-            </a:r>
-          </a:p>
-          <a:p>
-            <a:pPr>
-              <a:spcAft>
-                <a:spcPts val="1400"/>
-              </a:spcAft>
-              <a:defRPr sz="2600">
-                <a:solidFill>
-                  <a:srgbClr val="E8EEF4"/>
-                </a:solidFill>
-                <a:latin typeface="Calibri"/>
-              </a:defRPr>
-            </a:pPr>
-            <a:r>
-              <a:t>Eskaneo bat: hunter.io + aukeratutako modulua</a:t>
-            </a:r>
-          </a:p>
-        </p:txBody>
-      </p:sp>
-    </p:spTree>
-  </p:cSld>
-  <p:clrMapOvr>
-    <a:masterClrMapping/>
-  </p:clrMapOvr>
-</p:sld>
-</file>
-
-<file path=ppt/slides/slide21.xml><?xml version="1.0" encoding="utf-8"?>
-<p:sld xmlns:a="http://schemas.openxmlformats.org/drawingml/2006/main" xmlns:p="http://schemas.openxmlformats.org/presentationml/2006/main" xmlns:r="http://schemas.openxmlformats.org/officeDocument/2006/relationships">
-  <p:cSld>
-    <p:bg>
-      <p:bgPr>
-        <a:solidFill>
-          <a:srgbClr val="0F1419"/>
-        </a:solidFill>
-        <a:effectLst/>
-      </p:bgPr>
-    </p:bg>
-    <p:spTree>
-      <p:nvGrpSpPr>
-        <p:cNvPr id="1" name=""/>
-        <p:cNvGrpSpPr/>
-        <p:nvPr/>
-      </p:nvGrpSpPr>
-      <p:grpSpPr/>
-      <p:sp>
-        <p:nvSpPr>
-          <p:cNvPr id="2" name="TextBox 1"/>
-          <p:cNvSpPr txBox="1"/>
-          <p:nvPr/>
-        </p:nvSpPr>
-        <p:spPr>
-          <a:xfrm>
-            <a:off x="822960" y="1097280"/>
-            <a:ext cx="10058400" cy="731520"/>
-          </a:xfrm>
-          <a:prstGeom prst="rect">
-            <a:avLst/>
-          </a:prstGeom>
-          <a:noFill/>
-        </p:spPr>
-        <p:txBody>
-          <a:bodyPr wrap="square">
-            <a:spAutoFit/>
-          </a:bodyPr>
-          <a:lstStyle/>
-          <a:p>
-            <a:r>
-              <a:rPr sz="3600" b="1">
-                <a:solidFill>
-                  <a:srgbClr val="3D9EE5"/>
-                </a:solidFill>
-                <a:latin typeface="Calibri"/>
-              </a:rPr>
-              <a:t>Emaitza adibidea (SpiderFoot)</a:t>
-            </a:r>
-          </a:p>
-        </p:txBody>
-      </p:sp>
-      <p:sp>
-        <p:nvSpPr>
-          <p:cNvPr id="3" name="TextBox 2"/>
-          <p:cNvSpPr txBox="1"/>
-          <p:nvPr/>
-        </p:nvSpPr>
-        <p:spPr>
-          <a:xfrm>
-            <a:off x="822960" y="2194560"/>
-            <a:ext cx="10058400" cy="3657600"/>
-          </a:xfrm>
-          <a:prstGeom prst="rect">
-            <a:avLst/>
-          </a:prstGeom>
-          <a:noFill/>
-        </p:spPr>
-        <p:txBody>
-          <a:bodyPr wrap="square">
-            <a:spAutoFit/>
-          </a:bodyPr>
-          <a:lstStyle/>
-          <a:p>
-            <a:pPr>
-              <a:spcAft>
-                <a:spcPts val="1400"/>
-              </a:spcAft>
-              <a:defRPr sz="2600">
-                <a:solidFill>
-                  <a:srgbClr val="E8EEF4"/>
-                </a:solidFill>
-                <a:latin typeface="Calibri"/>
-              </a:defRPr>
-            </a:pPr>
-            <a:r>
-              <a:t>Helburua: example.com</a:t>
-            </a:r>
-          </a:p>
-          <a:p>
-            <a:pPr>
-              <a:spcAft>
-                <a:spcPts val="1400"/>
-              </a:spcAft>
-              <a:defRPr sz="2600">
-                <a:solidFill>
-                  <a:srgbClr val="E8EEF4"/>
-                </a:solidFill>
-                <a:latin typeface="Calibri"/>
-              </a:defRPr>
-            </a:pPr>
-            <a:r>
-              <a:t>Email: info@example.com, support@example.com</a:t>
-            </a:r>
-          </a:p>
-          <a:p>
-            <a:pPr>
-              <a:spcAft>
-                <a:spcPts val="1400"/>
-              </a:spcAft>
-              <a:defRPr sz="2600">
-                <a:solidFill>
-                  <a:srgbClr val="E8EEF4"/>
-                </a:solidFill>
-                <a:latin typeface="Calibri"/>
-              </a:defRPr>
-            </a:pPr>
-            <a:r>
-              <a:t>Azpidomeinuak: www, mail, cdn…</a:t>
-            </a:r>
-          </a:p>
-          <a:p>
-            <a:pPr>
-              <a:spcAft>
-                <a:spcPts val="1400"/>
-              </a:spcAft>
-              <a:defRPr sz="2600">
-                <a:solidFill>
-                  <a:srgbClr val="E8EEF4"/>
-                </a:solidFill>
-                <a:latin typeface="Calibri"/>
-              </a:defRPr>
-            </a:pPr>
-            <a:r>
-              <a:t>DNS / IP loturak eta web teknologia</a:t>
-            </a:r>
-          </a:p>
-          <a:p>
-            <a:pPr>
-              <a:spcAft>
-                <a:spcPts val="1400"/>
-              </a:spcAft>
-              <a:defRPr sz="2600">
-                <a:solidFill>
-                  <a:srgbClr val="E8EEF4"/>
-                </a:solidFill>
-                <a:latin typeface="Calibri"/>
-              </a:defRPr>
-            </a:pPr>
-            <a:r>
-              <a:t>Grafikoan nodoak eta loturak ikus daitezke.</a:t>
-            </a:r>
-          </a:p>
-        </p:txBody>
-      </p:sp>
-    </p:spTree>
-  </p:cSld>
-  <p:clrMapOvr>
-    <a:masterClrMapping/>
-  </p:clrMapOvr>
-</p:sld>
-</file>
-
-<file path=ppt/slides/slide22.xml><?xml version="1.0" encoding="utf-8"?>
-<p:sld xmlns:a="http://schemas.openxmlformats.org/drawingml/2006/main" xmlns:p="http://schemas.openxmlformats.org/presentationml/2006/main" xmlns:r="http://schemas.openxmlformats.org/officeDocument/2006/relationships">
-  <p:cSld>
-    <p:bg>
-      <p:bgPr>
-        <a:solidFill>
-          <a:srgbClr val="0F1419"/>
-        </a:solidFill>
-        <a:effectLst/>
-      </p:bgPr>
-    </p:bg>
-    <p:spTree>
-      <p:nvGrpSpPr>
-        <p:cNvPr id="1" name=""/>
-        <p:cNvGrpSpPr/>
-        <p:nvPr/>
-      </p:nvGrpSpPr>
-      <p:grpSpPr/>
-      <p:sp>
-        <p:nvSpPr>
-          <p:cNvPr id="2" name="TextBox 1"/>
-          <p:cNvSpPr txBox="1"/>
-          <p:nvPr/>
-        </p:nvSpPr>
-        <p:spPr>
-          <a:xfrm>
-            <a:off x="822960" y="1097280"/>
-            <a:ext cx="10058400" cy="731520"/>
-          </a:xfrm>
-          <a:prstGeom prst="rect">
-            <a:avLst/>
-          </a:prstGeom>
-          <a:noFill/>
-        </p:spPr>
-        <p:txBody>
-          <a:bodyPr wrap="square">
-            <a:spAutoFit/>
-          </a:bodyPr>
-          <a:lstStyle/>
-          <a:p>
-            <a:r>
-              <a:rPr sz="3600" b="1">
-                <a:solidFill>
-                  <a:srgbClr val="3D9EE5"/>
-                </a:solidFill>
-                <a:latin typeface="Calibri"/>
-              </a:rPr>
-              <a:t>Entregatu beharrekoa</a:t>
-            </a:r>
-          </a:p>
-        </p:txBody>
-      </p:sp>
-      <p:sp>
-        <p:nvSpPr>
-          <p:cNvPr id="3" name="TextBox 2"/>
-          <p:cNvSpPr txBox="1"/>
-          <p:nvPr/>
-        </p:nvSpPr>
-        <p:spPr>
-          <a:xfrm>
-            <a:off x="822960" y="2194560"/>
-            <a:ext cx="10058400" cy="3657600"/>
-          </a:xfrm>
-          <a:prstGeom prst="rect">
-            <a:avLst/>
-          </a:prstGeom>
-          <a:noFill/>
-        </p:spPr>
-        <p:txBody>
-          <a:bodyPr wrap="square">
-            <a:spAutoFit/>
-          </a:bodyPr>
-          <a:lstStyle/>
-          <a:p>
-            <a:pPr>
-              <a:spcAft>
-                <a:spcPts val="1400"/>
-              </a:spcAft>
-              <a:defRPr sz="2600">
-                <a:solidFill>
-                  <a:srgbClr val="E8EEF4"/>
-                </a:solidFill>
-                <a:latin typeface="Calibri"/>
-              </a:defRPr>
-            </a:pPr>
-            <a:r>
-              <a:t>Dokumentua: probaren urratsak + lortutako informazioa</a:t>
-            </a:r>
-          </a:p>
-          <a:p>
-            <a:pPr>
-              <a:spcAft>
-                <a:spcPts val="1400"/>
-              </a:spcAft>
-              <a:defRPr sz="2600">
-                <a:solidFill>
-                  <a:srgbClr val="E8EEF4"/>
-                </a:solidFill>
-                <a:latin typeface="Calibri"/>
-              </a:defRPr>
-            </a:pPr>
-            <a:r>
-              <a:t>Pantaila-argazkiak unean-unean</a:t>
-            </a:r>
-          </a:p>
-          <a:p>
-            <a:pPr>
-              <a:spcAft>
-                <a:spcPts val="1400"/>
-              </a:spcAft>
-              <a:defRPr sz="2600">
-                <a:solidFill>
-                  <a:srgbClr val="E8EEF4"/>
-                </a:solidFill>
-                <a:latin typeface="Calibri"/>
-              </a:defRPr>
-            </a:pPr>
-            <a:r>
-              <a:t>Esportazioak (CSV / txostenak) erantsi</a:t>
-            </a:r>
-          </a:p>
-        </p:txBody>
-      </p:sp>
-    </p:spTree>
-  </p:cSld>
-  <p:clrMapOvr>
-    <a:masterClrMapping/>
-  </p:clrMapOvr>
-</p:sld>
-</file>
-
-<file path=ppt/slides/slide23.xml><?xml version="1.0" encoding="utf-8"?>
-<p:sld xmlns:a="http://schemas.openxmlformats.org/drawingml/2006/main" xmlns:p="http://schemas.openxmlformats.org/presentationml/2006/main" xmlns:r="http://schemas.openxmlformats.org/officeDocument/2006/relationships">
-  <p:cSld>
-    <p:bg>
-      <p:bgPr>
-        <a:solidFill>
-          <a:srgbClr val="0F1419"/>
-        </a:solidFill>
-        <a:effectLst/>
-      </p:bgPr>
-    </p:bg>
-    <p:spTree>
-      <p:nvGrpSpPr>
-        <p:cNvPr id="1" name=""/>
-        <p:cNvGrpSpPr/>
-        <p:nvPr/>
-      </p:nvGrpSpPr>
-      <p:grpSpPr/>
-      <p:sp>
-        <p:nvSpPr>
-          <p:cNvPr id="2" name="TextBox 1"/>
-          <p:cNvSpPr txBox="1"/>
-          <p:nvPr/>
-        </p:nvSpPr>
-        <p:spPr>
-          <a:xfrm>
-            <a:off x="822960" y="1097280"/>
-            <a:ext cx="10058400" cy="731520"/>
-          </a:xfrm>
-          <a:prstGeom prst="rect">
-            <a:avLst/>
-          </a:prstGeom>
-          <a:noFill/>
-        </p:spPr>
-        <p:txBody>
-          <a:bodyPr wrap="square">
-            <a:spAutoFit/>
-          </a:bodyPr>
-          <a:lstStyle/>
-          <a:p>
-            <a:r>
-              <a:rPr sz="3600" b="1">
-                <a:solidFill>
-                  <a:srgbClr val="3D9EE5"/>
-                </a:solidFill>
-                <a:latin typeface="Calibri"/>
-              </a:rPr>
-              <a:t>Kontuan hartzekoa</a:t>
-            </a:r>
-          </a:p>
-        </p:txBody>
-      </p:sp>
-      <p:sp>
-        <p:nvSpPr>
-          <p:cNvPr id="3" name="TextBox 2"/>
-          <p:cNvSpPr txBox="1"/>
-          <p:nvPr/>
-        </p:nvSpPr>
-        <p:spPr>
-          <a:xfrm>
-            <a:off x="822960" y="2194560"/>
-            <a:ext cx="10058400" cy="3657600"/>
-          </a:xfrm>
-          <a:prstGeom prst="rect">
-            <a:avLst/>
-          </a:prstGeom>
-          <a:noFill/>
-        </p:spPr>
-        <p:txBody>
-          <a:bodyPr wrap="square">
-            <a:spAutoFit/>
-          </a:bodyPr>
-          <a:lstStyle/>
-          <a:p>
-            <a:pPr>
-              <a:spcAft>
-                <a:spcPts val="1400"/>
-              </a:spcAft>
-              <a:defRPr sz="2600">
-                <a:solidFill>
-                  <a:srgbClr val="E8EEF4"/>
-                </a:solidFill>
-                <a:latin typeface="Calibri"/>
-              </a:defRPr>
-            </a:pPr>
-            <a:r>
-              <a:t>Iturri publikoak eta legezkoak soilik.</a:t>
-            </a:r>
-          </a:p>
-          <a:p>
-            <a:pPr>
-              <a:spcAft>
-                <a:spcPts val="1400"/>
-              </a:spcAft>
-              <a:defRPr sz="2600">
-                <a:solidFill>
-                  <a:srgbClr val="E8EEF4"/>
-                </a:solidFill>
-                <a:latin typeface="Calibri"/>
-              </a:defRPr>
-            </a:pPr>
-            <a:r>
-              <a:t>Helburu propioak edo baimendutako domeinuak.</a:t>
-            </a:r>
-          </a:p>
-          <a:p>
-            <a:pPr>
-              <a:spcAft>
-                <a:spcPts val="1400"/>
-              </a:spcAft>
-              <a:defRPr sz="2600">
-                <a:solidFill>
-                  <a:srgbClr val="E8EEF4"/>
-                </a:solidFill>
-                <a:latin typeface="Calibri"/>
-              </a:defRPr>
-            </a:pPr>
-            <a:r>
-              <a:t>API key-ak sekretuak dira: ez partekatu txostenean.</a:t>
-            </a:r>
-          </a:p>
-        </p:txBody>
-      </p:sp>
-    </p:spTree>
-  </p:cSld>
-  <p:clrMapOvr>
-    <a:masterClrMapping/>
-  </p:clrMapOvr>
-</p:sld>
-</file>
-
-<file path=ppt/slides/slide24.xml><?xml version="1.0" encoding="utf-8"?>
-<p:sld xmlns:a="http://schemas.openxmlformats.org/drawingml/2006/main" xmlns:p="http://schemas.openxmlformats.org/presentationml/2006/main" xmlns:r="http://schemas.openxmlformats.org/officeDocument/2006/relationships">
-  <p:cSld>
-    <p:bg>
-      <p:bgPr>
-        <a:solidFill>
-          <a:srgbClr val="0F1419"/>
-        </a:solidFill>
-        <a:effectLst/>
-      </p:bgPr>
-    </p:bg>
-    <p:spTree>
-      <p:nvGrpSpPr>
-        <p:cNvPr id="1" name=""/>
-        <p:cNvGrpSpPr/>
-        <p:nvPr/>
-      </p:nvGrpSpPr>
-      <p:grpSpPr/>
-      <p:sp>
-        <p:nvSpPr>
-          <p:cNvPr id="2" name="TextBox 1"/>
-          <p:cNvSpPr txBox="1"/>
-          <p:nvPr/>
-        </p:nvSpPr>
-        <p:spPr>
-          <a:xfrm>
-            <a:off x="822960" y="2377440"/>
-            <a:ext cx="10058400" cy="914400"/>
-          </a:xfrm>
-          <a:prstGeom prst="rect">
-            <a:avLst/>
-          </a:prstGeom>
-          <a:noFill/>
-        </p:spPr>
-        <p:txBody>
-          <a:bodyPr wrap="square">
-            <a:spAutoFit/>
-          </a:bodyPr>
-          <a:lstStyle/>
-          <a:p>
-            <a:r>
-              <a:rPr sz="4800" b="1">
-                <a:solidFill>
-                  <a:srgbClr val="E8EEF4"/>
-                </a:solidFill>
-                <a:latin typeface="Calibri"/>
+            <a:off x="822960" y="2743200"/>
+            <a:ext cx="10515600" cy="914400"/>
+          </a:xfrm>
+          <a:prstGeom prst="rect">
+            <a:avLst/>
+          </a:prstGeom>
+          <a:noFill/>
+        </p:spPr>
+        <p:txBody>
+          <a:bodyPr wrap="none">
+            <a:spAutoFit/>
+          </a:bodyPr>
+          <a:lstStyle/>
+          <a:p>
+            <a:r>
+              <a:rPr sz="4200" b="1" i="0">
+                <a:solidFill>
+                  <a:srgbClr val="1A1A1A"/>
+                </a:solidFill>
+                <a:latin typeface="Raleway"/>
               </a:rPr>
               <a:t>Galderak?</a:t>
-            </a:r>
-          </a:p>
-        </p:txBody>
-      </p:sp>
-      <p:sp>
-        <p:nvSpPr>
-          <p:cNvPr id="3" name="TextBox 2"/>
-          <p:cNvSpPr txBox="1"/>
-          <p:nvPr/>
-        </p:nvSpPr>
-        <p:spPr>
-          <a:xfrm>
-            <a:off x="822960" y="3657600"/>
-            <a:ext cx="10058400" cy="914400"/>
-          </a:xfrm>
-          <a:prstGeom prst="rect">
-            <a:avLst/>
-          </a:prstGeom>
-          <a:noFill/>
-        </p:spPr>
-        <p:txBody>
-          <a:bodyPr wrap="square">
-            <a:spAutoFit/>
-          </a:bodyPr>
-          <a:lstStyle/>
-          <a:p>
-            <a:r>
-              <a:rPr sz="2200" b="0">
-                <a:solidFill>
-                  <a:srgbClr val="9AABBC"/>
-                </a:solidFill>
-                <a:latin typeface="Calibri"/>
-              </a:rPr>
-              <a:t>Hurrengoa: praktikak Kali-n (recon-ng) eta Docker-en (SpiderFoot)</a:t>
             </a:r>
           </a:p>
         </p:txBody>
@@ -5728,7 +5039,7 @@
     <p:bg>
       <p:bgPr>
         <a:solidFill>
-          <a:srgbClr val="0F1419"/>
+          <a:srgbClr val="E9EDEE"/>
         </a:solidFill>
         <a:effectLst/>
       </p:bgPr>
@@ -5748,26 +5059,26 @@
         </p:nvSpPr>
         <p:spPr>
           <a:xfrm>
-            <a:off x="822960" y="1097280"/>
-            <a:ext cx="10058400" cy="731520"/>
-          </a:xfrm>
-          <a:prstGeom prst="rect">
-            <a:avLst/>
-          </a:prstGeom>
-          <a:noFill/>
-        </p:spPr>
-        <p:txBody>
-          <a:bodyPr wrap="square">
-            <a:spAutoFit/>
-          </a:bodyPr>
-          <a:lstStyle/>
-          <a:p>
-            <a:r>
-              <a:rPr sz="3600" b="1">
-                <a:solidFill>
-                  <a:srgbClr val="3D9EE5"/>
-                </a:solidFill>
-                <a:latin typeface="Calibri"/>
+            <a:off x="822960" y="822960"/>
+            <a:ext cx="10515600" cy="822960"/>
+          </a:xfrm>
+          <a:prstGeom prst="rect">
+            <a:avLst/>
+          </a:prstGeom>
+          <a:noFill/>
+        </p:spPr>
+        <p:txBody>
+          <a:bodyPr wrap="square">
+            <a:spAutoFit/>
+          </a:bodyPr>
+          <a:lstStyle/>
+          <a:p>
+            <a:r>
+              <a:rPr sz="2400" b="1" i="0">
+                <a:solidFill>
+                  <a:srgbClr val="1A1A1A"/>
+                </a:solidFill>
+                <a:latin typeface="Raleway"/>
               </a:rPr>
               <a:t>Zertarako balio dute?</a:t>
             </a:r>
@@ -5782,65 +5093,96 @@
         </p:nvSpPr>
         <p:spPr>
           <a:xfrm>
-            <a:off x="822960" y="2194560"/>
-            <a:ext cx="10058400" cy="3657600"/>
-          </a:xfrm>
-          <a:prstGeom prst="rect">
-            <a:avLst/>
-          </a:prstGeom>
-          <a:noFill/>
-        </p:spPr>
-        <p:txBody>
-          <a:bodyPr wrap="square">
-            <a:spAutoFit/>
-          </a:bodyPr>
-          <a:lstStyle/>
-          <a:p>
-            <a:pPr>
-              <a:spcAft>
-                <a:spcPts val="1400"/>
-              </a:spcAft>
-              <a:defRPr sz="2600">
-                <a:solidFill>
-                  <a:srgbClr val="E8EEF4"/>
-                </a:solidFill>
-                <a:latin typeface="Calibri"/>
-              </a:defRPr>
-            </a:pPr>
-            <a:r>
-              <a:t>Domeinuei, webguneei, korreoei… buruzko datuak biltzeko.</a:t>
-            </a:r>
-          </a:p>
-          <a:p>
-            <a:pPr>
-              <a:spcAft>
-                <a:spcPts val="1400"/>
-              </a:spcAft>
-              <a:defRPr sz="2600">
-                <a:solidFill>
-                  <a:srgbClr val="E8EEF4"/>
-                </a:solidFill>
-                <a:latin typeface="Calibri"/>
-              </a:defRPr>
-            </a:pPr>
-            <a:r>
-              <a:t>Beste zerbitzuen API-ak bateratzeko toki bakarrean.</a:t>
-            </a:r>
-          </a:p>
-          <a:p>
-            <a:pPr>
-              <a:spcAft>
-                <a:spcPts val="1400"/>
-              </a:spcAft>
-              <a:defRPr sz="2600">
-                <a:solidFill>
-                  <a:srgbClr val="E8EEF4"/>
-                </a:solidFill>
-                <a:latin typeface="Calibri"/>
-              </a:defRPr>
-            </a:pPr>
-            <a:r>
-              <a:t>Eskuz orduak hartuko luketen bilaketak errazteko.</a:t>
+            <a:off x="822960" y="1920240"/>
+            <a:ext cx="10515600" cy="777240"/>
+          </a:xfrm>
+          <a:prstGeom prst="rect">
+            <a:avLst/>
+          </a:prstGeom>
+          <a:noFill/>
+        </p:spPr>
+        <p:txBody>
+          <a:bodyPr wrap="square">
+            <a:spAutoFit/>
+          </a:bodyPr>
+          <a:lstStyle/>
+          <a:p>
+            <a:r>
+              <a:rPr sz="2300" b="0" i="0">
+                <a:solidFill>
+                  <a:srgbClr val="1A1A1A"/>
+                </a:solidFill>
+                <a:latin typeface="Raleway"/>
+              </a:rPr>
+              <a:t>- Lan errepikakorrak edo automatizagarriak errazteko.</a:t>
+            </a:r>
+          </a:p>
+        </p:txBody>
+      </p:sp>
+      <p:sp>
+        <p:nvSpPr>
+          <p:cNvPr id="4" name="TextBox 3"/>
+          <p:cNvSpPr txBox="1"/>
+          <p:nvPr/>
+        </p:nvSpPr>
+        <p:spPr>
+          <a:xfrm>
+            <a:off x="822960" y="2450592"/>
+            <a:ext cx="10515600" cy="777240"/>
+          </a:xfrm>
+          <a:prstGeom prst="rect">
+            <a:avLst/>
+          </a:prstGeom>
+          <a:noFill/>
+        </p:spPr>
+        <p:txBody>
+          <a:bodyPr wrap="square">
+            <a:spAutoFit/>
+          </a:bodyPr>
+          <a:lstStyle/>
+          <a:p>
+            <a:r>
+              <a:rPr sz="2300" b="0" i="0">
+                <a:solidFill>
+                  <a:srgbClr val="1A1A1A"/>
+                </a:solidFill>
+                <a:latin typeface="Raleway"/>
+              </a:rPr>
+              <a:t>- Domeinu, webgune, korreo… buruzko informazioa biltzeko.</a:t>
+            </a:r>
+          </a:p>
+        </p:txBody>
+      </p:sp>
+      <p:sp>
+        <p:nvSpPr>
+          <p:cNvPr id="5" name="TextBox 4"/>
+          <p:cNvSpPr txBox="1"/>
+          <p:nvPr/>
+        </p:nvSpPr>
+        <p:spPr>
+          <a:xfrm>
+            <a:off x="822960" y="2980944"/>
+            <a:ext cx="10515600" cy="777240"/>
+          </a:xfrm>
+          <a:prstGeom prst="rect">
+            <a:avLst/>
+          </a:prstGeom>
+          <a:noFill/>
+        </p:spPr>
+        <p:txBody>
+          <a:bodyPr wrap="square">
+            <a:spAutoFit/>
+          </a:bodyPr>
+          <a:lstStyle/>
+          <a:p>
+            <a:r>
+              <a:rPr sz="2300" b="0" i="0">
+                <a:solidFill>
+                  <a:srgbClr val="1A1A1A"/>
+                </a:solidFill>
+                <a:latin typeface="Raleway"/>
+              </a:rPr>
+              <a:t>- Beste zerbitzuen API-ak toki bakarrean integratzeko.</a:t>
             </a:r>
           </a:p>
         </p:txBody>
@@ -5859,7 +5201,7 @@
     <p:bg>
       <p:bgPr>
         <a:solidFill>
-          <a:srgbClr val="0F1419"/>
+          <a:srgbClr val="E9EDEE"/>
         </a:solidFill>
         <a:effectLst/>
       </p:bgPr>
@@ -5879,26 +5221,26 @@
         </p:nvSpPr>
         <p:spPr>
           <a:xfrm>
-            <a:off x="822960" y="1097280"/>
-            <a:ext cx="10058400" cy="731520"/>
-          </a:xfrm>
-          <a:prstGeom prst="rect">
-            <a:avLst/>
-          </a:prstGeom>
-          <a:noFill/>
-        </p:spPr>
-        <p:txBody>
-          <a:bodyPr wrap="square">
-            <a:spAutoFit/>
-          </a:bodyPr>
-          <a:lstStyle/>
-          <a:p>
-            <a:r>
-              <a:rPr sz="3600" b="1">
-                <a:solidFill>
-                  <a:srgbClr val="3D9EE5"/>
-                </a:solidFill>
-                <a:latin typeface="Calibri"/>
+            <a:off x="822960" y="822960"/>
+            <a:ext cx="10515600" cy="822960"/>
+          </a:xfrm>
+          <a:prstGeom prst="rect">
+            <a:avLst/>
+          </a:prstGeom>
+          <a:noFill/>
+        </p:spPr>
+        <p:txBody>
+          <a:bodyPr wrap="square">
+            <a:spAutoFit/>
+          </a:bodyPr>
+          <a:lstStyle/>
+          <a:p>
+            <a:r>
+              <a:rPr sz="2400" b="1" i="0">
+                <a:solidFill>
+                  <a:srgbClr val="1A1A1A"/>
+                </a:solidFill>
+                <a:latin typeface="Raleway"/>
               </a:rPr>
               <a:t>Zer informazio lor dezakegu</a:t>
             </a:r>
@@ -5913,97 +5255,130 @@
         </p:nvSpPr>
         <p:spPr>
           <a:xfrm>
-            <a:off x="822960" y="2194560"/>
-            <a:ext cx="10058400" cy="3657600"/>
-          </a:xfrm>
-          <a:prstGeom prst="rect">
-            <a:avLst/>
-          </a:prstGeom>
-          <a:noFill/>
-        </p:spPr>
-        <p:txBody>
-          <a:bodyPr wrap="square">
-            <a:spAutoFit/>
-          </a:bodyPr>
-          <a:lstStyle/>
-          <a:p>
-            <a:pPr>
-              <a:spcAft>
-                <a:spcPts val="1400"/>
-              </a:spcAft>
-              <a:defRPr sz="2600">
-                <a:solidFill>
-                  <a:srgbClr val="E8EEF4"/>
-                </a:solidFill>
-                <a:latin typeface="Calibri"/>
-              </a:defRPr>
-            </a:pPr>
-            <a:r>
-              <a:t>Azpidomeinuak eta hostak</a:t>
-            </a:r>
-          </a:p>
-          <a:p>
-            <a:pPr>
-              <a:spcAft>
-                <a:spcPts val="1400"/>
-              </a:spcAft>
-              <a:defRPr sz="2600">
-                <a:solidFill>
-                  <a:srgbClr val="E8EEF4"/>
-                </a:solidFill>
-                <a:latin typeface="Calibri"/>
-              </a:defRPr>
-            </a:pPr>
-            <a:r>
-              <a:t>IP helbideak</a:t>
-            </a:r>
-          </a:p>
-          <a:p>
-            <a:pPr>
-              <a:spcAft>
-                <a:spcPts val="1400"/>
-              </a:spcAft>
-              <a:defRPr sz="2600">
-                <a:solidFill>
-                  <a:srgbClr val="E8EEF4"/>
-                </a:solidFill>
-                <a:latin typeface="Calibri"/>
-              </a:defRPr>
-            </a:pPr>
-            <a:r>
-              <a:t>Korreo helbideak</a:t>
-            </a:r>
-          </a:p>
-          <a:p>
-            <a:pPr>
-              <a:spcAft>
-                <a:spcPts val="1400"/>
-              </a:spcAft>
-              <a:defRPr sz="2600">
-                <a:solidFill>
-                  <a:srgbClr val="E8EEF4"/>
-                </a:solidFill>
-                <a:latin typeface="Calibri"/>
-              </a:defRPr>
-            </a:pPr>
-            <a:r>
-              <a:t>DNS / WHOIS / web teknologia</a:t>
-            </a:r>
-          </a:p>
-          <a:p>
-            <a:pPr>
-              <a:spcAft>
-                <a:spcPts val="1400"/>
-              </a:spcAft>
-              <a:defRPr sz="2600">
-                <a:solidFill>
-                  <a:srgbClr val="E8EEF4"/>
-                </a:solidFill>
-                <a:latin typeface="Calibri"/>
-              </a:defRPr>
-            </a:pPr>
-            <a:r>
-              <a:t>Sare sozialetako arrastoak</a:t>
+            <a:off x="822960" y="1920240"/>
+            <a:ext cx="10515600" cy="777240"/>
+          </a:xfrm>
+          <a:prstGeom prst="rect">
+            <a:avLst/>
+          </a:prstGeom>
+          <a:noFill/>
+        </p:spPr>
+        <p:txBody>
+          <a:bodyPr wrap="square">
+            <a:spAutoFit/>
+          </a:bodyPr>
+          <a:lstStyle/>
+          <a:p>
+            <a:r>
+              <a:rPr sz="2300" b="0" i="0">
+                <a:solidFill>
+                  <a:srgbClr val="1A1A1A"/>
+                </a:solidFill>
+                <a:latin typeface="Raleway"/>
+              </a:rPr>
+              <a:t>- Domeinuei eta azpidomeinuei buruzkoa</a:t>
+            </a:r>
+          </a:p>
+        </p:txBody>
+      </p:sp>
+      <p:sp>
+        <p:nvSpPr>
+          <p:cNvPr id="4" name="TextBox 3"/>
+          <p:cNvSpPr txBox="1"/>
+          <p:nvPr/>
+        </p:nvSpPr>
+        <p:spPr>
+          <a:xfrm>
+            <a:off x="822960" y="2450592"/>
+            <a:ext cx="10515600" cy="777240"/>
+          </a:xfrm>
+          <a:prstGeom prst="rect">
+            <a:avLst/>
+          </a:prstGeom>
+          <a:noFill/>
+        </p:spPr>
+        <p:txBody>
+          <a:bodyPr wrap="square">
+            <a:spAutoFit/>
+          </a:bodyPr>
+          <a:lstStyle/>
+          <a:p>
+            <a:r>
+              <a:rPr sz="2300" b="0" i="0">
+                <a:solidFill>
+                  <a:srgbClr val="1A1A1A"/>
+                </a:solidFill>
+                <a:latin typeface="Raleway"/>
+              </a:rPr>
+              <a:t>- Webguneei buruzkoa</a:t>
+            </a:r>
+          </a:p>
+        </p:txBody>
+      </p:sp>
+      <p:sp>
+        <p:nvSpPr>
+          <p:cNvPr id="5" name="TextBox 4"/>
+          <p:cNvSpPr txBox="1"/>
+          <p:nvPr/>
+        </p:nvSpPr>
+        <p:spPr>
+          <a:xfrm>
+            <a:off x="822960" y="2980944"/>
+            <a:ext cx="10515600" cy="777240"/>
+          </a:xfrm>
+          <a:prstGeom prst="rect">
+            <a:avLst/>
+          </a:prstGeom>
+          <a:noFill/>
+        </p:spPr>
+        <p:txBody>
+          <a:bodyPr wrap="square">
+            <a:spAutoFit/>
+          </a:bodyPr>
+          <a:lstStyle/>
+          <a:p>
+            <a:r>
+              <a:rPr sz="2300" b="0" i="0">
+                <a:solidFill>
+                  <a:srgbClr val="1A1A1A"/>
+                </a:solidFill>
+                <a:latin typeface="Raleway"/>
+              </a:rPr>
+              <a:t>- Korreo helbideak eta kontaktuak</a:t>
+            </a:r>
+          </a:p>
+        </p:txBody>
+      </p:sp>
+      <p:sp>
+        <p:nvSpPr>
+          <p:cNvPr id="6" name="TextBox 5"/>
+          <p:cNvSpPr txBox="1"/>
+          <p:nvPr/>
+        </p:nvSpPr>
+        <p:spPr>
+          <a:xfrm>
+            <a:off x="822960" y="3511296"/>
+            <a:ext cx="10515600" cy="777240"/>
+          </a:xfrm>
+          <a:prstGeom prst="rect">
+            <a:avLst/>
+          </a:prstGeom>
+          <a:noFill/>
+        </p:spPr>
+        <p:txBody>
+          <a:bodyPr wrap="square">
+            <a:spAutoFit/>
+          </a:bodyPr>
+          <a:lstStyle/>
+          <a:p>
+            <a:r>
+              <a:rPr sz="2300" b="0" i="0">
+                <a:solidFill>
+                  <a:srgbClr val="1A1A1A"/>
+                </a:solidFill>
+                <a:latin typeface="Raleway"/>
+              </a:rPr>
+              <a:t>- DNS, IP eta online presentzia</a:t>
             </a:r>
           </a:p>
         </p:txBody>
@@ -6022,7 +5397,7 @@
     <p:bg>
       <p:bgPr>
         <a:solidFill>
-          <a:srgbClr val="0F1419"/>
+          <a:srgbClr val="E9EDEE"/>
         </a:solidFill>
         <a:effectLst/>
       </p:bgPr>
@@ -6042,28 +5417,28 @@
         </p:nvSpPr>
         <p:spPr>
           <a:xfrm>
-            <a:off x="822960" y="1097280"/>
-            <a:ext cx="10058400" cy="731520"/>
-          </a:xfrm>
-          <a:prstGeom prst="rect">
-            <a:avLst/>
-          </a:prstGeom>
-          <a:noFill/>
-        </p:spPr>
-        <p:txBody>
-          <a:bodyPr wrap="square">
-            <a:spAutoFit/>
-          </a:bodyPr>
-          <a:lstStyle/>
-          <a:p>
-            <a:r>
-              <a:rPr sz="3600" b="1">
-                <a:solidFill>
-                  <a:srgbClr val="3D9EE5"/>
-                </a:solidFill>
-                <a:latin typeface="Calibri"/>
-              </a:rPr>
-              <a:t>API key-ak — garrantzitsua</a:t>
+            <a:off x="822960" y="822960"/>
+            <a:ext cx="10515600" cy="822960"/>
+          </a:xfrm>
+          <a:prstGeom prst="rect">
+            <a:avLst/>
+          </a:prstGeom>
+          <a:noFill/>
+        </p:spPr>
+        <p:txBody>
+          <a:bodyPr wrap="square">
+            <a:spAutoFit/>
+          </a:bodyPr>
+          <a:lstStyle/>
+          <a:p>
+            <a:r>
+              <a:rPr sz="2400" b="1" i="0">
+                <a:solidFill>
+                  <a:srgbClr val="1A1A1A"/>
+                </a:solidFill>
+                <a:latin typeface="Raleway"/>
+              </a:rPr>
+              <a:t>Kontuan hartzekoa</a:t>
             </a:r>
           </a:p>
         </p:txBody>
@@ -6076,81 +5451,28 @@
         </p:nvSpPr>
         <p:spPr>
           <a:xfrm>
-            <a:off x="822960" y="2194560"/>
-            <a:ext cx="10058400" cy="3657600"/>
-          </a:xfrm>
-          <a:prstGeom prst="rect">
-            <a:avLst/>
-          </a:prstGeom>
-          <a:noFill/>
-        </p:spPr>
-        <p:txBody>
-          <a:bodyPr wrap="square">
-            <a:spAutoFit/>
-          </a:bodyPr>
-          <a:lstStyle/>
-          <a:p>
-            <a:pPr>
-              <a:spcAft>
-                <a:spcPts val="1400"/>
-              </a:spcAft>
-              <a:defRPr sz="2600">
-                <a:solidFill>
-                  <a:srgbClr val="E8EEF4"/>
-                </a:solidFill>
-                <a:latin typeface="Calibri"/>
-              </a:defRPr>
-            </a:pPr>
-            <a:r>
-              <a:t>Emaitza onak lortzeko, askotan API key behar da.</a:t>
-            </a:r>
-          </a:p>
-          <a:p>
-            <a:pPr>
-              <a:spcAft>
-                <a:spcPts val="1400"/>
-              </a:spcAft>
-              <a:defRPr sz="2600">
-                <a:solidFill>
-                  <a:srgbClr val="E8EEF4"/>
-                </a:solidFill>
-                <a:latin typeface="Calibri"/>
-              </a:defRPr>
-            </a:pPr>
-            <a:r>
-              <a:t>Zerbitzu horietan erregistratu behar gara.</a:t>
-            </a:r>
-          </a:p>
-          <a:p>
-            <a:pPr>
-              <a:spcAft>
-                <a:spcPts val="1400"/>
-              </a:spcAft>
-              <a:defRPr sz="2600">
-                <a:solidFill>
-                  <a:srgbClr val="E8EEF4"/>
-                </a:solidFill>
-                <a:latin typeface="Calibri"/>
-              </a:defRPr>
-            </a:pPr>
-            <a:r>
-              <a:t>Doako planak egon daitezke; batzuetan ez.</a:t>
-            </a:r>
-          </a:p>
-          <a:p>
-            <a:pPr>
-              <a:spcAft>
-                <a:spcPts val="1400"/>
-              </a:spcAft>
-              <a:defRPr sz="2600">
-                <a:solidFill>
-                  <a:srgbClr val="E8EEF4"/>
-                </a:solidFill>
-                <a:latin typeface="Calibri"/>
-              </a:defRPr>
-            </a:pPr>
-            <a:r>
-              <a:t>Key gabe: modulu batzuk hutsik edo mugatuta.</a:t>
+            <a:off x="822960" y="2103120"/>
+            <a:ext cx="10515600" cy="777240"/>
+          </a:xfrm>
+          <a:prstGeom prst="rect">
+            <a:avLst/>
+          </a:prstGeom>
+          <a:noFill/>
+        </p:spPr>
+        <p:txBody>
+          <a:bodyPr wrap="square">
+            <a:spAutoFit/>
+          </a:bodyPr>
+          <a:lstStyle/>
+          <a:p>
+            <a:r>
+              <a:rPr sz="2300" b="0" i="1">
+                <a:solidFill>
+                  <a:srgbClr val="1A1A1A"/>
+                </a:solidFill>
+                <a:latin typeface="Raleway"/>
+              </a:rPr>
+              <a:t>Emaitza onak lortzeko, askotan API key-ak behar dira.</a:t>
             </a:r>
           </a:p>
         </p:txBody>
@@ -6169,7 +5491,7 @@
     <p:bg>
       <p:bgPr>
         <a:solidFill>
-          <a:srgbClr val="0F1419"/>
+          <a:srgbClr val="E9EDEE"/>
         </a:solidFill>
         <a:effectLst/>
       </p:bgPr>
@@ -6189,28 +5511,28 @@
         </p:nvSpPr>
         <p:spPr>
           <a:xfrm>
-            <a:off x="822960" y="1097280"/>
-            <a:ext cx="10058400" cy="731520"/>
-          </a:xfrm>
-          <a:prstGeom prst="rect">
-            <a:avLst/>
-          </a:prstGeom>
-          <a:noFill/>
-        </p:spPr>
-        <p:txBody>
-          <a:bodyPr wrap="square">
-            <a:spAutoFit/>
-          </a:bodyPr>
-          <a:lstStyle/>
-          <a:p>
-            <a:r>
-              <a:rPr sz="3600" b="1">
-                <a:solidFill>
-                  <a:srgbClr val="3D9EE5"/>
-                </a:solidFill>
-                <a:latin typeface="Calibri"/>
-              </a:rPr>
-              <a:t>API adibideak</a:t>
+            <a:off x="822960" y="822960"/>
+            <a:ext cx="10515600" cy="822960"/>
+          </a:xfrm>
+          <a:prstGeom prst="rect">
+            <a:avLst/>
+          </a:prstGeom>
+          <a:noFill/>
+        </p:spPr>
+        <p:txBody>
+          <a:bodyPr wrap="square">
+            <a:spAutoFit/>
+          </a:bodyPr>
+          <a:lstStyle/>
+          <a:p>
+            <a:r>
+              <a:rPr sz="2400" b="1" i="0">
+                <a:solidFill>
+                  <a:srgbClr val="1A1A1A"/>
+                </a:solidFill>
+                <a:latin typeface="Raleway"/>
+              </a:rPr>
+              <a:t>Kontuan hartzekoa</a:t>
             </a:r>
           </a:p>
         </p:txBody>
@@ -6223,81 +5545,96 @@
         </p:nvSpPr>
         <p:spPr>
           <a:xfrm>
-            <a:off x="822960" y="2194560"/>
-            <a:ext cx="10058400" cy="3657600"/>
-          </a:xfrm>
-          <a:prstGeom prst="rect">
-            <a:avLst/>
-          </a:prstGeom>
-          <a:noFill/>
-        </p:spPr>
-        <p:txBody>
-          <a:bodyPr wrap="square">
-            <a:spAutoFit/>
-          </a:bodyPr>
-          <a:lstStyle/>
-          <a:p>
-            <a:pPr>
-              <a:spcAft>
-                <a:spcPts val="1400"/>
-              </a:spcAft>
-              <a:defRPr sz="2600">
-                <a:solidFill>
-                  <a:srgbClr val="E8EEF4"/>
-                </a:solidFill>
-                <a:latin typeface="Calibri"/>
-              </a:defRPr>
-            </a:pPr>
-            <a:r>
-              <a:t>Hunter.io — korreo bilaketa</a:t>
-            </a:r>
-          </a:p>
-          <a:p>
-            <a:pPr>
-              <a:spcAft>
-                <a:spcPts val="1400"/>
-              </a:spcAft>
-              <a:defRPr sz="2600">
-                <a:solidFill>
-                  <a:srgbClr val="E8EEF4"/>
-                </a:solidFill>
-                <a:latin typeface="Calibri"/>
-              </a:defRPr>
-            </a:pPr>
-            <a:r>
-              <a:t>Shodan — Interneteko host/portuak</a:t>
-            </a:r>
-          </a:p>
-          <a:p>
-            <a:pPr>
-              <a:spcAft>
-                <a:spcPts val="1400"/>
-              </a:spcAft>
-              <a:defRPr sz="2600">
-                <a:solidFill>
-                  <a:srgbClr val="E8EEF4"/>
-                </a:solidFill>
-                <a:latin typeface="Calibri"/>
-              </a:defRPr>
-            </a:pPr>
-            <a:r>
-              <a:t>HackerTarget — azpidomeinuak (maiz key gabe / muga)</a:t>
-            </a:r>
-          </a:p>
-          <a:p>
-            <a:pPr>
-              <a:spcAft>
-                <a:spcPts val="1400"/>
-              </a:spcAft>
-              <a:defRPr sz="2600">
-                <a:solidFill>
-                  <a:srgbClr val="E8EEF4"/>
-                </a:solidFill>
-                <a:latin typeface="Calibri"/>
-              </a:defRPr>
-            </a:pPr>
-            <a:r>
-              <a:t>GitHub, Virustotal… — beste moduluak</a:t>
+            <a:off x="822960" y="1920240"/>
+            <a:ext cx="10515600" cy="777240"/>
+          </a:xfrm>
+          <a:prstGeom prst="rect">
+            <a:avLst/>
+          </a:prstGeom>
+          <a:noFill/>
+        </p:spPr>
+        <p:txBody>
+          <a:bodyPr wrap="square">
+            <a:spAutoFit/>
+          </a:bodyPr>
+          <a:lstStyle/>
+          <a:p>
+            <a:r>
+              <a:rPr sz="2300" b="0" i="1">
+                <a:solidFill>
+                  <a:srgbClr val="1A1A1A"/>
+                </a:solidFill>
+                <a:latin typeface="Raleway"/>
+              </a:rPr>
+              <a:t>Emaitza onak lortzeko, askotan API key-ak behar dira.</a:t>
+            </a:r>
+          </a:p>
+        </p:txBody>
+      </p:sp>
+      <p:sp>
+        <p:nvSpPr>
+          <p:cNvPr id="4" name="TextBox 3"/>
+          <p:cNvSpPr txBox="1"/>
+          <p:nvPr/>
+        </p:nvSpPr>
+        <p:spPr>
+          <a:xfrm>
+            <a:off x="822960" y="2514600"/>
+            <a:ext cx="10515600" cy="777240"/>
+          </a:xfrm>
+          <a:prstGeom prst="rect">
+            <a:avLst/>
+          </a:prstGeom>
+          <a:noFill/>
+        </p:spPr>
+        <p:txBody>
+          <a:bodyPr wrap="square">
+            <a:spAutoFit/>
+          </a:bodyPr>
+          <a:lstStyle/>
+          <a:p>
+            <a:r>
+              <a:rPr sz="2300" b="0" i="1">
+                <a:solidFill>
+                  <a:srgbClr val="1A1A1A"/>
+                </a:solidFill>
+                <a:latin typeface="Raleway"/>
+              </a:rPr>
+              <a:t/>
+            </a:r>
+          </a:p>
+        </p:txBody>
+      </p:sp>
+      <p:sp>
+        <p:nvSpPr>
+          <p:cNvPr id="5" name="TextBox 4"/>
+          <p:cNvSpPr txBox="1"/>
+          <p:nvPr/>
+        </p:nvSpPr>
+        <p:spPr>
+          <a:xfrm>
+            <a:off x="822960" y="3108960"/>
+            <a:ext cx="10515600" cy="777240"/>
+          </a:xfrm>
+          <a:prstGeom prst="rect">
+            <a:avLst/>
+          </a:prstGeom>
+          <a:noFill/>
+        </p:spPr>
+        <p:txBody>
+          <a:bodyPr wrap="square">
+            <a:spAutoFit/>
+          </a:bodyPr>
+          <a:lstStyle/>
+          <a:p>
+            <a:r>
+              <a:rPr sz="2300" b="0" i="1">
+                <a:solidFill>
+                  <a:srgbClr val="1A1A1A"/>
+                </a:solidFill>
+                <a:latin typeface="Raleway"/>
+              </a:rPr>
+              <a:t>Horretarako zerbitzu horietan erregistratu behar gara.</a:t>
             </a:r>
           </a:p>
         </p:txBody>
@@ -6316,7 +5653,7 @@
     <p:bg>
       <p:bgPr>
         <a:solidFill>
-          <a:srgbClr val="0F1419"/>
+          <a:srgbClr val="E9EDEE"/>
         </a:solidFill>
         <a:effectLst/>
       </p:bgPr>
@@ -6336,28 +5673,28 @@
         </p:nvSpPr>
         <p:spPr>
           <a:xfrm>
-            <a:off x="822960" y="2560320"/>
-            <a:ext cx="10058400" cy="914400"/>
-          </a:xfrm>
-          <a:prstGeom prst="rect">
-            <a:avLst/>
-          </a:prstGeom>
-          <a:noFill/>
-        </p:spPr>
-        <p:txBody>
-          <a:bodyPr wrap="square">
-            <a:spAutoFit/>
-          </a:bodyPr>
-          <a:lstStyle/>
-          <a:p>
-            <a:r>
-              <a:rPr sz="4800" b="1">
-                <a:solidFill>
-                  <a:srgbClr val="E8EEF4"/>
-                </a:solidFill>
-                <a:latin typeface="Calibri"/>
-              </a:rPr>
-              <a:t>recon-ng</a:t>
+            <a:off x="822960" y="822960"/>
+            <a:ext cx="10515600" cy="822960"/>
+          </a:xfrm>
+          <a:prstGeom prst="rect">
+            <a:avLst/>
+          </a:prstGeom>
+          <a:noFill/>
+        </p:spPr>
+        <p:txBody>
+          <a:bodyPr wrap="square">
+            <a:spAutoFit/>
+          </a:bodyPr>
+          <a:lstStyle/>
+          <a:p>
+            <a:r>
+              <a:rPr sz="2400" b="1" i="0">
+                <a:solidFill>
+                  <a:srgbClr val="1A1A1A"/>
+                </a:solidFill>
+                <a:latin typeface="Raleway"/>
+              </a:rPr>
+              <a:t>Kontuan hartzekoa</a:t>
             </a:r>
           </a:p>
         </p:txBody>
@@ -6370,28 +5707,96 @@
         </p:nvSpPr>
         <p:spPr>
           <a:xfrm>
-            <a:off x="822960" y="3657600"/>
-            <a:ext cx="10058400" cy="548640"/>
-          </a:xfrm>
-          <a:prstGeom prst="rect">
-            <a:avLst/>
-          </a:prstGeom>
-          <a:noFill/>
-        </p:spPr>
-        <p:txBody>
-          <a:bodyPr wrap="square">
-            <a:spAutoFit/>
-          </a:bodyPr>
-          <a:lstStyle/>
-          <a:p>
-            <a:r>
-              <a:rPr sz="2600" b="0">
-                <a:solidFill>
-                  <a:srgbClr val="9AABBC"/>
-                </a:solidFill>
-                <a:latin typeface="Calibri"/>
-              </a:rPr>
-              <a:t>OSINT framework — komando-lerroa</a:t>
+            <a:off x="822960" y="1920240"/>
+            <a:ext cx="10515600" cy="777240"/>
+          </a:xfrm>
+          <a:prstGeom prst="rect">
+            <a:avLst/>
+          </a:prstGeom>
+          <a:noFill/>
+        </p:spPr>
+        <p:txBody>
+          <a:bodyPr wrap="square">
+            <a:spAutoFit/>
+          </a:bodyPr>
+          <a:lstStyle/>
+          <a:p>
+            <a:r>
+              <a:rPr sz="2300" b="0" i="0">
+                <a:solidFill>
+                  <a:srgbClr val="1A1A1A"/>
+                </a:solidFill>
+                <a:latin typeface="Raleway"/>
+              </a:rPr>
+              <a:t>- API key gabe, modulu askok ez dute emaitzarik ematen.</a:t>
+            </a:r>
+          </a:p>
+        </p:txBody>
+      </p:sp>
+      <p:sp>
+        <p:nvSpPr>
+          <p:cNvPr id="4" name="TextBox 3"/>
+          <p:cNvSpPr txBox="1"/>
+          <p:nvPr/>
+        </p:nvSpPr>
+        <p:spPr>
+          <a:xfrm>
+            <a:off x="822960" y="2450592"/>
+            <a:ext cx="10515600" cy="777240"/>
+          </a:xfrm>
+          <a:prstGeom prst="rect">
+            <a:avLst/>
+          </a:prstGeom>
+          <a:noFill/>
+        </p:spPr>
+        <p:txBody>
+          <a:bodyPr wrap="square">
+            <a:spAutoFit/>
+          </a:bodyPr>
+          <a:lstStyle/>
+          <a:p>
+            <a:r>
+              <a:rPr sz="2300" b="0" i="0">
+                <a:solidFill>
+                  <a:srgbClr val="1A1A1A"/>
+                </a:solidFill>
+                <a:latin typeface="Raleway"/>
+              </a:rPr>
+              <a:t>- Doako planak egon daitezke; batzuetan ez.</a:t>
+            </a:r>
+          </a:p>
+        </p:txBody>
+      </p:sp>
+      <p:sp>
+        <p:nvSpPr>
+          <p:cNvPr id="5" name="TextBox 4"/>
+          <p:cNvSpPr txBox="1"/>
+          <p:nvPr/>
+        </p:nvSpPr>
+        <p:spPr>
+          <a:xfrm>
+            <a:off x="822960" y="2980944"/>
+            <a:ext cx="10515600" cy="777240"/>
+          </a:xfrm>
+          <a:prstGeom prst="rect">
+            <a:avLst/>
+          </a:prstGeom>
+          <a:noFill/>
+        </p:spPr>
+        <p:txBody>
+          <a:bodyPr wrap="square">
+            <a:spAutoFit/>
+          </a:bodyPr>
+          <a:lstStyle/>
+          <a:p>
+            <a:r>
+              <a:rPr sz="2300" b="0" i="0">
+                <a:solidFill>
+                  <a:srgbClr val="1A1A1A"/>
+                </a:solidFill>
+                <a:latin typeface="Raleway"/>
+              </a:rPr>
+              <a:t>- Key-ak sekretuak dira: ez partekatu txostenetan.</a:t>
             </a:r>
           </a:p>
         </p:txBody>
@@ -6410,7 +5815,7 @@
     <p:bg>
       <p:bgPr>
         <a:solidFill>
-          <a:srgbClr val="0F1419"/>
+          <a:srgbClr val="E9EDEE"/>
         </a:solidFill>
         <a:effectLst/>
       </p:bgPr>
@@ -6430,99 +5835,28 @@
         </p:nvSpPr>
         <p:spPr>
           <a:xfrm>
-            <a:off x="822960" y="1097280"/>
-            <a:ext cx="10058400" cy="731520"/>
-          </a:xfrm>
-          <a:prstGeom prst="rect">
-            <a:avLst/>
-          </a:prstGeom>
-          <a:noFill/>
-        </p:spPr>
-        <p:txBody>
-          <a:bodyPr wrap="square">
-            <a:spAutoFit/>
-          </a:bodyPr>
-          <a:lstStyle/>
-          <a:p>
-            <a:r>
-              <a:rPr sz="3600" b="1">
-                <a:solidFill>
-                  <a:srgbClr val="3D9EE5"/>
-                </a:solidFill>
-                <a:latin typeface="Calibri"/>
-              </a:rPr>
-              <a:t>Zer da recon-ng?</a:t>
-            </a:r>
-          </a:p>
-        </p:txBody>
-      </p:sp>
-      <p:sp>
-        <p:nvSpPr>
-          <p:cNvPr id="3" name="TextBox 2"/>
-          <p:cNvSpPr txBox="1"/>
-          <p:nvPr/>
-        </p:nvSpPr>
-        <p:spPr>
-          <a:xfrm>
-            <a:off x="822960" y="2194560"/>
-            <a:ext cx="10058400" cy="3657600"/>
-          </a:xfrm>
-          <a:prstGeom prst="rect">
-            <a:avLst/>
-          </a:prstGeom>
-          <a:noFill/>
-        </p:spPr>
-        <p:txBody>
-          <a:bodyPr wrap="square">
-            <a:spAutoFit/>
-          </a:bodyPr>
-          <a:lstStyle/>
-          <a:p>
-            <a:pPr>
-              <a:spcAft>
-                <a:spcPts val="1400"/>
-              </a:spcAft>
-              <a:defRPr sz="2600">
-                <a:solidFill>
-                  <a:srgbClr val="E8EEF4"/>
-                </a:solidFill>
-                <a:latin typeface="Calibri"/>
-              </a:defRPr>
-            </a:pPr>
-            <a:r>
-              <a:t>Kali-n instalatuta etortzen den tresna.</a:t>
-            </a:r>
-          </a:p>
-          <a:p>
-            <a:pPr>
-              <a:spcAft>
-                <a:spcPts val="1400"/>
-              </a:spcAft>
-              <a:defRPr sz="2600">
-                <a:solidFill>
-                  <a:srgbClr val="E8EEF4"/>
-                </a:solidFill>
-                <a:latin typeface="Calibri"/>
-              </a:defRPr>
-            </a:pPr>
-            <a:r>
-              <a:t>Moduluetan oinarritutako framework-a.</a:t>
-            </a:r>
-          </a:p>
-          <a:p>
-            <a:pPr>
-              <a:spcAft>
-                <a:spcPts val="1400"/>
-              </a:spcAft>
-              <a:defRPr sz="2600">
-                <a:solidFill>
-                  <a:srgbClr val="E8EEF4"/>
-                </a:solidFill>
-                <a:latin typeface="Calibri"/>
-              </a:defRPr>
-            </a:pPr>
-            <a:r>
-              <a:t>Emaitzak workspace / datu-basean gordetzen ditu.</a:t>
+            <a:off x="822960" y="2743200"/>
+            <a:ext cx="10515600" cy="914400"/>
+          </a:xfrm>
+          <a:prstGeom prst="rect">
+            <a:avLst/>
+          </a:prstGeom>
+          <a:noFill/>
+        </p:spPr>
+        <p:txBody>
+          <a:bodyPr wrap="none">
+            <a:spAutoFit/>
+          </a:bodyPr>
+          <a:lstStyle/>
+          <a:p>
+            <a:r>
+              <a:rPr sz="4200" b="1" i="0">
+                <a:solidFill>
+                  <a:srgbClr val="1A1A1A"/>
+                </a:solidFill>
+                <a:latin typeface="Raleway"/>
+              </a:rPr>
+              <a:t>recon-ng</a:t>
             </a:r>
           </a:p>
         </p:txBody>
@@ -6541,7 +5875,7 @@
     <p:bg>
       <p:bgPr>
         <a:solidFill>
-          <a:srgbClr val="0F1419"/>
+          <a:srgbClr val="E9EDEE"/>
         </a:solidFill>
         <a:effectLst/>
       </p:bgPr>
@@ -6561,28 +5895,28 @@
         </p:nvSpPr>
         <p:spPr>
           <a:xfrm>
-            <a:off x="822960" y="1097280"/>
-            <a:ext cx="10058400" cy="731520"/>
-          </a:xfrm>
-          <a:prstGeom prst="rect">
-            <a:avLst/>
-          </a:prstGeom>
-          <a:noFill/>
-        </p:spPr>
-        <p:txBody>
-          <a:bodyPr wrap="square">
-            <a:spAutoFit/>
-          </a:bodyPr>
-          <a:lstStyle/>
-          <a:p>
-            <a:r>
-              <a:rPr sz="3600" b="1">
-                <a:solidFill>
-                  <a:srgbClr val="3D9EE5"/>
-                </a:solidFill>
-                <a:latin typeface="Calibri"/>
-              </a:rPr>
-              <a:t>Nabigazio kontekstuala</a:t>
+            <a:off x="822960" y="822960"/>
+            <a:ext cx="10515600" cy="822960"/>
+          </a:xfrm>
+          <a:prstGeom prst="rect">
+            <a:avLst/>
+          </a:prstGeom>
+          <a:noFill/>
+        </p:spPr>
+        <p:txBody>
+          <a:bodyPr wrap="square">
+            <a:spAutoFit/>
+          </a:bodyPr>
+          <a:lstStyle/>
+          <a:p>
+            <a:r>
+              <a:rPr sz="2400" b="1" i="0">
+                <a:solidFill>
+                  <a:srgbClr val="1A1A1A"/>
+                </a:solidFill>
+                <a:latin typeface="Raleway"/>
+              </a:rPr>
+              <a:t>Zer da recon-ng?</a:t>
             </a:r>
           </a:p>
         </p:txBody>
@@ -6595,28 +5929,28 @@
         </p:nvSpPr>
         <p:spPr>
           <a:xfrm>
-            <a:off x="822960" y="2377440"/>
-            <a:ext cx="10058400" cy="548640"/>
-          </a:xfrm>
-          <a:prstGeom prst="rect">
-            <a:avLst/>
-          </a:prstGeom>
-          <a:noFill/>
-        </p:spPr>
-        <p:txBody>
-          <a:bodyPr wrap="square">
-            <a:spAutoFit/>
-          </a:bodyPr>
-          <a:lstStyle/>
-          <a:p>
-            <a:r>
-              <a:rPr sz="2800" b="0">
-                <a:solidFill>
-                  <a:srgbClr val="E8EEF4"/>
-                </a:solidFill>
-                <a:latin typeface="Calibri"/>
-              </a:rPr>
-              <a:t>Workspaces  →  proiektua / helburua</a:t>
+            <a:off x="822960" y="1920240"/>
+            <a:ext cx="10515600" cy="777240"/>
+          </a:xfrm>
+          <a:prstGeom prst="rect">
+            <a:avLst/>
+          </a:prstGeom>
+          <a:noFill/>
+        </p:spPr>
+        <p:txBody>
+          <a:bodyPr wrap="square">
+            <a:spAutoFit/>
+          </a:bodyPr>
+          <a:lstStyle/>
+          <a:p>
+            <a:r>
+              <a:rPr sz="2300" b="0" i="0">
+                <a:solidFill>
+                  <a:srgbClr val="1A1A1A"/>
+                </a:solidFill>
+                <a:latin typeface="Raleway"/>
+              </a:rPr>
+              <a:t>- OSINT / ezagutze lanetarako framework bat.</a:t>
             </a:r>
           </a:p>
         </p:txBody>
@@ -6629,28 +5963,28 @@
         </p:nvSpPr>
         <p:spPr>
           <a:xfrm>
-            <a:off x="822960" y="3108960"/>
-            <a:ext cx="10058400" cy="548640"/>
-          </a:xfrm>
-          <a:prstGeom prst="rect">
-            <a:avLst/>
-          </a:prstGeom>
-          <a:noFill/>
-        </p:spPr>
-        <p:txBody>
-          <a:bodyPr wrap="square">
-            <a:spAutoFit/>
-          </a:bodyPr>
-          <a:lstStyle/>
-          <a:p>
-            <a:r>
-              <a:rPr sz="2800" b="0">
-                <a:solidFill>
-                  <a:srgbClr val="E8EEF4"/>
-                </a:solidFill>
-                <a:latin typeface="Calibri"/>
-              </a:rPr>
-              <a:t>Modules  →  bilaketa-tresna bakoitza</a:t>
+            <a:off x="822960" y="2450592"/>
+            <a:ext cx="10515600" cy="777240"/>
+          </a:xfrm>
+          <a:prstGeom prst="rect">
+            <a:avLst/>
+          </a:prstGeom>
+          <a:noFill/>
+        </p:spPr>
+        <p:txBody>
+          <a:bodyPr wrap="square">
+            <a:spAutoFit/>
+          </a:bodyPr>
+          <a:lstStyle/>
+          <a:p>
+            <a:r>
+              <a:rPr sz="2300" b="0" i="0">
+                <a:solidFill>
+                  <a:srgbClr val="1A1A1A"/>
+                </a:solidFill>
+                <a:latin typeface="Raleway"/>
+              </a:rPr>
+              <a:t>- Kali-n instalatuta etortzen da.</a:t>
             </a:r>
           </a:p>
         </p:txBody>
@@ -6663,28 +5997,28 @@
         </p:nvSpPr>
         <p:spPr>
           <a:xfrm>
-            <a:off x="822960" y="4114800"/>
-            <a:ext cx="10058400" cy="731520"/>
-          </a:xfrm>
-          <a:prstGeom prst="rect">
-            <a:avLst/>
-          </a:prstGeom>
-          <a:noFill/>
-        </p:spPr>
-        <p:txBody>
-          <a:bodyPr wrap="square">
-            <a:spAutoFit/>
-          </a:bodyPr>
-          <a:lstStyle/>
-          <a:p>
-            <a:r>
-              <a:rPr sz="2000" b="0">
-                <a:solidFill>
-                  <a:srgbClr val="9AABBC"/>
-                </a:solidFill>
-                <a:latin typeface="Calibri"/>
-              </a:rPr>
-              <a:t>Mailaka mugitzen gara; maila bakoitzean aukera desberdinak.</a:t>
+            <a:off x="822960" y="2980944"/>
+            <a:ext cx="10515600" cy="777240"/>
+          </a:xfrm>
+          <a:prstGeom prst="rect">
+            <a:avLst/>
+          </a:prstGeom>
+          <a:noFill/>
+        </p:spPr>
+        <p:txBody>
+          <a:bodyPr wrap="square">
+            <a:spAutoFit/>
+          </a:bodyPr>
+          <a:lstStyle/>
+          <a:p>
+            <a:r>
+              <a:rPr sz="2300" b="0" i="0">
+                <a:solidFill>
+                  <a:srgbClr val="1A1A1A"/>
+                </a:solidFill>
+                <a:latin typeface="Raleway"/>
+              </a:rPr>
+              <a:t>- Komando-lerrotik erabiltzen da.</a:t>
             </a:r>
           </a:p>
         </p:txBody>

</xml_diff>